<commit_message>
docs: pitch deck v2 — owner content, emoji chips, short fragments
</commit_message>
<xml_diff>
--- a/docs/presentation/enjoy-pitch.pptx
+++ b/docs/presentation/enjoy-pitch.pptx
@@ -509,7 +509,7 @@
           <a:lstStyle/>
           <a:p>
             <a:r>
-              <a:t>0:00-0:10 — Say: 'This is enjoy — a calm ocean world that does the busywork of studying for you.' Then cut straight to the problem.</a:t>
+              <a:t>0:00-0:10 — 'This is enjoy — a calm ocean world that does the busywork of studying for you.'</a:t>
             </a:r>
           </a:p>
         </p:txBody>
@@ -579,7 +579,7 @@
           <a:lstStyle/>
           <a:p>
             <a:r>
-              <a:t>0:10-0:25 — Pain first, one breath per bullet. Land on: 'none of that is learning — it's overhead.'</a:t>
+              <a:t>0:10-0:25 — owner's framing: stress, burden, wasted time, chatbot shortcut. Land on: 'none of that is learning.'</a:t>
             </a:r>
           </a:p>
         </p:txBody>
@@ -649,7 +649,7 @@
           <a:lstStyle/>
           <a:p>
             <a:r>
-              <a:t>0:25-0:40 — The metaphor in one breath. 'No streaks, no guilt — the lamp only records victories.' Then: 'let me show you.'</a:t>
+              <a:t>0:25-0:40 — three offers, one breath each. Then: 'let me show you.'</a:t>
             </a:r>
           </a:p>
         </p:txBody>
@@ -719,7 +719,7 @@
           <a:lstStyle/>
           <a:p>
             <a:r>
-              <a:t>0:40-1:05 — CUT TO GAMEPLAY here. Type the sentence live, let the tour offer and boat spawn play. Voiceover: 'The orchestrator routes it, the planner templates it, the world shows it.'</a:t>
+              <a:t>0:40-1:05 — CUT TO GAMEPLAY A. 'The orchestrator routes it, the planner templates it, the world shows it.'</a:t>
             </a:r>
           </a:p>
         </p:txBody>
@@ -789,7 +789,7 @@
           <a:lstStyle/>
           <a:p>
             <a:r>
-              <a:t>1:05-1:30 — CUT TO GAMEPLAY. Play the recorded review loop. Voiceover: 'Real retrieval practice — the AI never answers for you, it just removes everything else.'</a:t>
+              <a:t>1:05-1:30 — CUT TO GAMEPLAY B. 'The AI never answers for you — it removes everything else.'</a:t>
             </a:r>
           </a:p>
         </p:txBody>
@@ -859,7 +859,7 @@
           <a:lstStyle/>
           <a:p>
             <a:r>
-              <a:t>1:30-1:45 — CUT TO GAMEPLAY: dive, pan the atlas, open one node. Voiceover: 'Your portfolio isn't a chart — it's a place.'</a:t>
+              <a:t>1:30-1:45 — CUT TO GAMEPLAY C: dive, pan, one node drawer, surface.</a:t>
             </a:r>
           </a:p>
         </p:txBody>
@@ -929,7 +929,7 @@
           <a:lstStyle/>
           <a:p>
             <a:r>
-              <a:t>1:45-1:55 — Technical credibility in ten seconds. Don't read the bullets; say: 'agents do the plumbing, Postgres is the single truth, and the AI never studies FOR you.'</a:t>
+              <a:t>1:45-1:55 — don't read bullets; 'agents do the plumbing, Postgres is the single truth, AI never studies FOR you.'</a:t>
             </a:r>
           </a:p>
         </p:txBody>
@@ -999,7 +999,7 @@
           <a:lstStyle/>
           <a:p>
             <a:r>
-              <a:t>1:55-2:00 — Slow down. One line: 'A returning student is welcomed, never billed for absence. Thank you.' End on the lamp shot if you have one.</a:t>
+              <a:t>1:55-2:00 — slow: 'A returning student is welcomed, never billed for absence. Thank you.'</a:t>
             </a:r>
           </a:p>
         </p:txBody>
@@ -4021,8 +4021,8 @@
         </p:nvSpPr>
         <p:spPr>
           <a:xfrm>
-            <a:off x="0" y="5394960"/>
-            <a:ext cx="12191695" cy="109728"/>
+            <a:off x="0" y="5257800"/>
+            <a:ext cx="12191695" cy="91440"/>
           </a:xfrm>
           <a:prstGeom prst="rect">
             <a:avLst/>
@@ -4065,8 +4065,8 @@
         </p:nvSpPr>
         <p:spPr>
           <a:xfrm>
-            <a:off x="914400" y="1920240"/>
-            <a:ext cx="10362895" cy="2377440"/>
+            <a:off x="914400" y="822960"/>
+            <a:ext cx="10332720" cy="914400"/>
           </a:xfrm>
           <a:prstGeom prst="rect">
             <a:avLst/>
@@ -4081,11 +4081,50 @@
           <a:p>
             <a:pPr algn="ctr">
               <a:spcAft>
-                <a:spcPts val="1000"/>
+                <a:spcPts val="800"/>
               </a:spcAft>
             </a:pPr>
             <a:r>
-              <a:rPr sz="9600" b="1">
+              <a:rPr sz="4000" b="0">
+                <a:solidFill>
+                  <a:srgbClr val="F7F7F0"/>
+                </a:solidFill>
+                <a:latin typeface="Segoe UI Emoji"/>
+              </a:rPr>
+              <a:t>🌊 ⛵ 🏮</a:t>
+            </a:r>
+          </a:p>
+        </p:txBody>
+      </p:sp>
+      <p:sp>
+        <p:nvSpPr>
+          <p:cNvPr id="4" name="TextBox 3"/>
+          <p:cNvSpPr txBox="1"/>
+          <p:nvPr/>
+        </p:nvSpPr>
+        <p:spPr>
+          <a:xfrm>
+            <a:off x="914400" y="1737360"/>
+            <a:ext cx="10332720" cy="2377440"/>
+          </a:xfrm>
+          <a:prstGeom prst="rect">
+            <a:avLst/>
+          </a:prstGeom>
+          <a:noFill/>
+        </p:spPr>
+        <p:txBody>
+          <a:bodyPr wrap="square">
+            <a:spAutoFit/>
+          </a:bodyPr>
+          <a:lstStyle/>
+          <a:p>
+            <a:pPr algn="ctr">
+              <a:spcAft>
+                <a:spcPts val="800"/>
+              </a:spcAft>
+            </a:pPr>
+            <a:r>
+              <a:rPr sz="10000" b="1">
                 <a:solidFill>
                   <a:srgbClr val="F7F7F0"/>
                 </a:solidFill>
@@ -4097,11 +4136,11 @@
           <a:p>
             <a:pPr algn="ctr">
               <a:spcAft>
-                <a:spcPts val="1000"/>
+                <a:spcPts val="800"/>
               </a:spcAft>
             </a:pPr>
             <a:r>
-              <a:rPr sz="3600" b="0">
+              <a:rPr sz="3400" b="0">
                 <a:solidFill>
                   <a:srgbClr val="E8B46A"/>
                 </a:solidFill>
@@ -4114,14 +4153,14 @@
       </p:sp>
       <p:sp>
         <p:nvSpPr>
-          <p:cNvPr id="4" name="TextBox 3"/>
+          <p:cNvPr id="5" name="TextBox 4"/>
           <p:cNvSpPr txBox="1"/>
           <p:nvPr/>
         </p:nvSpPr>
         <p:spPr>
           <a:xfrm>
-            <a:off x="914400" y="4572000"/>
-            <a:ext cx="10362895" cy="731520"/>
+            <a:off x="914400" y="4297680"/>
+            <a:ext cx="10332720" cy="731520"/>
           </a:xfrm>
           <a:prstGeom prst="rect">
             <a:avLst/>
@@ -4136,7 +4175,7 @@
           <a:p>
             <a:pPr algn="ctr">
               <a:spcAft>
-                <a:spcPts val="1000"/>
+                <a:spcPts val="800"/>
               </a:spcAft>
             </a:pPr>
             <a:r>
@@ -4146,7 +4185,129 @@
                 </a:solidFill>
                 <a:latin typeface="Segoe UI"/>
               </a:rPr>
-              <a:t>A cozy ocean world that automates studying.</a:t>
+              <a:t>a cozy ocean world that automates studying</a:t>
+            </a:r>
+          </a:p>
+        </p:txBody>
+      </p:sp>
+      <p:sp>
+        <p:nvSpPr>
+          <p:cNvPr id="6" name="Rectangle 5"/>
+          <p:cNvSpPr/>
+          <p:nvPr/>
+        </p:nvSpPr>
+        <p:spPr>
+          <a:xfrm>
+            <a:off x="502920" y="6473952"/>
+            <a:ext cx="457200" cy="41148"/>
+          </a:xfrm>
+          <a:prstGeom prst="rect">
+            <a:avLst/>
+          </a:prstGeom>
+          <a:solidFill>
+            <a:srgbClr val="D8E4E0"/>
+          </a:solidFill>
+          <a:ln>
+            <a:noFill/>
+          </a:ln>
+          <a:effectLst/>
+        </p:spPr>
+        <p:style>
+          <a:lnRef idx="1">
+            <a:schemeClr val="accent1"/>
+          </a:lnRef>
+          <a:fillRef idx="3">
+            <a:schemeClr val="accent1"/>
+          </a:fillRef>
+          <a:effectRef idx="2">
+            <a:schemeClr val="accent1"/>
+          </a:effectRef>
+          <a:fontRef idx="minor">
+            <a:schemeClr val="lt1"/>
+          </a:fontRef>
+        </p:style>
+        <p:txBody>
+          <a:bodyPr rtlCol="0" anchor="ctr"/>
+          <a:lstStyle/>
+          <a:p>
+            <a:pPr algn="ctr"/>
+          </a:p>
+        </p:txBody>
+      </p:sp>
+      <p:sp>
+        <p:nvSpPr>
+          <p:cNvPr id="7" name="TextBox 6"/>
+          <p:cNvSpPr txBox="1"/>
+          <p:nvPr/>
+        </p:nvSpPr>
+        <p:spPr>
+          <a:xfrm>
+            <a:off x="502920" y="6108192"/>
+            <a:ext cx="2743200" cy="365760"/>
+          </a:xfrm>
+          <a:prstGeom prst="rect">
+            <a:avLst/>
+          </a:prstGeom>
+          <a:noFill/>
+        </p:spPr>
+        <p:txBody>
+          <a:bodyPr wrap="square">
+            <a:spAutoFit/>
+          </a:bodyPr>
+          <a:lstStyle/>
+          <a:p>
+            <a:pPr algn="l">
+              <a:spcAft>
+                <a:spcPts val="800"/>
+              </a:spcAft>
+            </a:pPr>
+            <a:r>
+              <a:rPr sz="1200" b="1">
+                <a:solidFill>
+                  <a:srgbClr val="D8E4E0"/>
+                </a:solidFill>
+                <a:latin typeface="Segoe UI"/>
+              </a:rPr>
+              <a:t>enjoy ⚓</a:t>
+            </a:r>
+          </a:p>
+        </p:txBody>
+      </p:sp>
+      <p:sp>
+        <p:nvSpPr>
+          <p:cNvPr id="8" name="TextBox 7"/>
+          <p:cNvSpPr txBox="1"/>
+          <p:nvPr/>
+        </p:nvSpPr>
+        <p:spPr>
+          <a:xfrm>
+            <a:off x="11155680" y="6108192"/>
+            <a:ext cx="548640" cy="365760"/>
+          </a:xfrm>
+          <a:prstGeom prst="rect">
+            <a:avLst/>
+          </a:prstGeom>
+          <a:noFill/>
+        </p:spPr>
+        <p:txBody>
+          <a:bodyPr wrap="square">
+            <a:spAutoFit/>
+          </a:bodyPr>
+          <a:lstStyle/>
+          <a:p>
+            <a:pPr algn="r">
+              <a:spcAft>
+                <a:spcPts val="800"/>
+              </a:spcAft>
+            </a:pPr>
+            <a:r>
+              <a:rPr sz="1200" b="1">
+                <a:solidFill>
+                  <a:srgbClr val="D8E4E0"/>
+                </a:solidFill>
+                <a:latin typeface="Segoe UI"/>
+              </a:rPr>
+              <a:t>01</a:t>
             </a:r>
           </a:p>
         </p:txBody>
@@ -4185,8 +4346,8 @@
         </p:nvSpPr>
         <p:spPr>
           <a:xfrm>
-            <a:off x="914400" y="731520"/>
-            <a:ext cx="10362895" cy="914400"/>
+            <a:off x="822960" y="502920"/>
+            <a:ext cx="5486400" cy="457200"/>
           </a:xfrm>
           <a:prstGeom prst="rect">
             <a:avLst/>
@@ -4199,33 +4360,116 @@
           </a:bodyPr>
           <a:lstStyle/>
           <a:p>
-            <a:pPr algn="ctr">
+            <a:pPr algn="l">
               <a:spcAft>
-                <a:spcPts val="1000"/>
+                <a:spcPts val="800"/>
               </a:spcAft>
             </a:pPr>
             <a:r>
-              <a:rPr sz="4000" b="1">
+              <a:rPr sz="1600" b="1">
+                <a:solidFill>
+                  <a:srgbClr val="0F4C5C"/>
+                </a:solidFill>
+                <a:latin typeface="Segoe UI"/>
+              </a:rPr>
+              <a:t>THE PROBLEM 😰</a:t>
+            </a:r>
+          </a:p>
+        </p:txBody>
+      </p:sp>
+      <p:sp>
+        <p:nvSpPr>
+          <p:cNvPr id="3" name="TextBox 2"/>
+          <p:cNvSpPr txBox="1"/>
+          <p:nvPr/>
+        </p:nvSpPr>
+        <p:spPr>
+          <a:xfrm>
+            <a:off x="777240" y="914400"/>
+            <a:ext cx="10607040" cy="1188720"/>
+          </a:xfrm>
+          <a:prstGeom prst="rect">
+            <a:avLst/>
+          </a:prstGeom>
+          <a:noFill/>
+        </p:spPr>
+        <p:txBody>
+          <a:bodyPr wrap="square">
+            <a:spAutoFit/>
+          </a:bodyPr>
+          <a:lstStyle/>
+          <a:p>
+            <a:pPr algn="l">
+              <a:spcAft>
+                <a:spcPts val="800"/>
+              </a:spcAft>
+            </a:pPr>
+            <a:r>
+              <a:rPr sz="4400" b="1">
                 <a:solidFill>
                   <a:srgbClr val="1A203B"/>
                 </a:solidFill>
                 <a:latin typeface="Segoe UI"/>
               </a:rPr>
-              <a:t>Students don't drown in learning.</a:t>
-            </a:r>
-          </a:p>
-        </p:txBody>
-      </p:sp>
-      <p:sp>
-        <p:nvSpPr>
-          <p:cNvPr id="3" name="TextBox 2"/>
+              <a:t>Students are stressed out 🎓💦</a:t>
+            </a:r>
+          </a:p>
+        </p:txBody>
+      </p:sp>
+      <p:sp>
+        <p:nvSpPr>
+          <p:cNvPr id="4" name="Rounded Rectangle 3"/>
+          <p:cNvSpPr/>
+          <p:nvPr/>
+        </p:nvSpPr>
+        <p:spPr>
+          <a:xfrm>
+            <a:off x="1005840" y="2331720"/>
+            <a:ext cx="10149840" cy="868680"/>
+          </a:xfrm>
+          <a:prstGeom prst="roundRect">
+            <a:avLst/>
+          </a:prstGeom>
+          <a:solidFill>
+            <a:srgbClr val="FFFFF8"/>
+          </a:solidFill>
+          <a:ln>
+            <a:noFill/>
+          </a:ln>
+          <a:effectLst/>
+        </p:spPr>
+        <p:style>
+          <a:lnRef idx="1">
+            <a:schemeClr val="accent1"/>
+          </a:lnRef>
+          <a:fillRef idx="3">
+            <a:schemeClr val="accent1"/>
+          </a:fillRef>
+          <a:effectRef idx="2">
+            <a:schemeClr val="accent1"/>
+          </a:effectRef>
+          <a:fontRef idx="minor">
+            <a:schemeClr val="lt1"/>
+          </a:fontRef>
+        </p:style>
+        <p:txBody>
+          <a:bodyPr rtlCol="0" anchor="ctr"/>
+          <a:lstStyle/>
+          <a:p>
+            <a:pPr algn="ctr"/>
+          </a:p>
+        </p:txBody>
+      </p:sp>
+      <p:sp>
+        <p:nvSpPr>
+          <p:cNvPr id="5" name="TextBox 4"/>
           <p:cNvSpPr txBox="1"/>
           <p:nvPr/>
         </p:nvSpPr>
         <p:spPr>
           <a:xfrm>
-            <a:off x="1463040" y="2011680"/>
-            <a:ext cx="9235440" cy="3291840"/>
+            <a:off x="1325880" y="2441448"/>
+            <a:ext cx="9509760" cy="649224"/>
           </a:xfrm>
           <a:prstGeom prst="rect">
             <a:avLst/>
@@ -4238,25 +4482,9 @@
           </a:bodyPr>
           <a:lstStyle/>
           <a:p>
-            <a:pPr algn="ctr">
+            <a:pPr algn="l">
               <a:spcAft>
-                <a:spcPts val="1000"/>
-              </a:spcAft>
-            </a:pPr>
-            <a:r>
-              <a:rPr sz="2600" b="0">
-                <a:solidFill>
-                  <a:srgbClr val="0F4C5C"/>
-                </a:solidFill>
-                <a:latin typeface="Segoe UI"/>
-              </a:rPr>
-              <a:t>They drown in the work AROUND it:</a:t>
-            </a:r>
-          </a:p>
-          <a:p>
-            <a:pPr algn="ctr">
-              <a:spcAft>
-                <a:spcPts val="1000"/>
+                <a:spcPts val="800"/>
               </a:spcAft>
             </a:pPr>
             <a:r>
@@ -4266,13 +4494,80 @@
                 </a:solidFill>
                 <a:latin typeface="Segoe UI"/>
               </a:rPr>
-              <a:t>planning what to study   ·   formatting flashcards</a:t>
-            </a:r>
-          </a:p>
-          <a:p>
-            <a:pPr algn="ctr">
+              <a:t>📚  current edtech  →  adds MORE burden</a:t>
+            </a:r>
+          </a:p>
+        </p:txBody>
+      </p:sp>
+      <p:sp>
+        <p:nvSpPr>
+          <p:cNvPr id="6" name="Rounded Rectangle 5"/>
+          <p:cNvSpPr/>
+          <p:nvPr/>
+        </p:nvSpPr>
+        <p:spPr>
+          <a:xfrm>
+            <a:off x="1005840" y="3429000"/>
+            <a:ext cx="10149840" cy="868680"/>
+          </a:xfrm>
+          <a:prstGeom prst="roundRect">
+            <a:avLst/>
+          </a:prstGeom>
+          <a:solidFill>
+            <a:srgbClr val="FFFFF8"/>
+          </a:solidFill>
+          <a:ln>
+            <a:noFill/>
+          </a:ln>
+          <a:effectLst/>
+        </p:spPr>
+        <p:style>
+          <a:lnRef idx="1">
+            <a:schemeClr val="accent1"/>
+          </a:lnRef>
+          <a:fillRef idx="3">
+            <a:schemeClr val="accent1"/>
+          </a:fillRef>
+          <a:effectRef idx="2">
+            <a:schemeClr val="accent1"/>
+          </a:effectRef>
+          <a:fontRef idx="minor">
+            <a:schemeClr val="lt1"/>
+          </a:fontRef>
+        </p:style>
+        <p:txBody>
+          <a:bodyPr rtlCol="0" anchor="ctr"/>
+          <a:lstStyle/>
+          <a:p>
+            <a:pPr algn="ctr"/>
+          </a:p>
+        </p:txBody>
+      </p:sp>
+      <p:sp>
+        <p:nvSpPr>
+          <p:cNvPr id="7" name="TextBox 6"/>
+          <p:cNvSpPr txBox="1"/>
+          <p:nvPr/>
+        </p:nvSpPr>
+        <p:spPr>
+          <a:xfrm>
+            <a:off x="1325880" y="3538728"/>
+            <a:ext cx="9509760" cy="649224"/>
+          </a:xfrm>
+          <a:prstGeom prst="rect">
+            <a:avLst/>
+          </a:prstGeom>
+          <a:noFill/>
+        </p:spPr>
+        <p:txBody>
+          <a:bodyPr wrap="square">
+            <a:spAutoFit/>
+          </a:bodyPr>
+          <a:lstStyle/>
+          <a:p>
+            <a:pPr algn="l">
               <a:spcAft>
-                <a:spcPts val="1000"/>
+                <a:spcPts val="800"/>
               </a:spcAft>
             </a:pPr>
             <a:r>
@@ -4282,23 +4577,212 @@
                 </a:solidFill>
                 <a:latin typeface="Segoe UI"/>
               </a:rPr>
-              <a:t>scheduling reviews   ·   tracking progress</a:t>
-            </a:r>
-          </a:p>
-          <a:p>
-            <a:pPr algn="ctr">
+              <a:t>⏳  time wasted on tools  →  better spent learning yourself</a:t>
+            </a:r>
+          </a:p>
+        </p:txBody>
+      </p:sp>
+      <p:sp>
+        <p:nvSpPr>
+          <p:cNvPr id="8" name="Rounded Rectangle 7"/>
+          <p:cNvSpPr/>
+          <p:nvPr/>
+        </p:nvSpPr>
+        <p:spPr>
+          <a:xfrm>
+            <a:off x="1005840" y="4526280"/>
+            <a:ext cx="10149840" cy="868680"/>
+          </a:xfrm>
+          <a:prstGeom prst="roundRect">
+            <a:avLst/>
+          </a:prstGeom>
+          <a:solidFill>
+            <a:srgbClr val="FFFFF8"/>
+          </a:solidFill>
+          <a:ln>
+            <a:noFill/>
+          </a:ln>
+          <a:effectLst/>
+        </p:spPr>
+        <p:style>
+          <a:lnRef idx="1">
+            <a:schemeClr val="accent1"/>
+          </a:lnRef>
+          <a:fillRef idx="3">
+            <a:schemeClr val="accent1"/>
+          </a:fillRef>
+          <a:effectRef idx="2">
+            <a:schemeClr val="accent1"/>
+          </a:effectRef>
+          <a:fontRef idx="minor">
+            <a:schemeClr val="lt1"/>
+          </a:fontRef>
+        </p:style>
+        <p:txBody>
+          <a:bodyPr rtlCol="0" anchor="ctr"/>
+          <a:lstStyle/>
+          <a:p>
+            <a:pPr algn="ctr"/>
+          </a:p>
+        </p:txBody>
+      </p:sp>
+      <p:sp>
+        <p:nvSpPr>
+          <p:cNvPr id="9" name="TextBox 8"/>
+          <p:cNvSpPr txBox="1"/>
+          <p:nvPr/>
+        </p:nvSpPr>
+        <p:spPr>
+          <a:xfrm>
+            <a:off x="1325880" y="4636008"/>
+            <a:ext cx="9509760" cy="649224"/>
+          </a:xfrm>
+          <a:prstGeom prst="rect">
+            <a:avLst/>
+          </a:prstGeom>
+          <a:noFill/>
+        </p:spPr>
+        <p:txBody>
+          <a:bodyPr wrap="square">
+            <a:spAutoFit/>
+          </a:bodyPr>
+          <a:lstStyle/>
+          <a:p>
+            <a:pPr algn="l">
               <a:spcAft>
-                <a:spcPts val="1000"/>
+                <a:spcPts val="800"/>
               </a:spcAft>
             </a:pPr>
             <a:r>
-              <a:rPr sz="2400" b="1">
+              <a:rPr sz="2400" b="0">
                 <a:solidFill>
-                  <a:srgbClr val="E8B46A"/>
+                  <a:srgbClr val="1A203B"/>
                 </a:solidFill>
                 <a:latin typeface="Segoe UI"/>
               </a:rPr>
-              <a:t>That's extraneous load — and it eats the evening.</a:t>
+              <a:t>🤖  or a chatbot finishes the work  →  nothing is learned</a:t>
+            </a:r>
+          </a:p>
+        </p:txBody>
+      </p:sp>
+      <p:sp>
+        <p:nvSpPr>
+          <p:cNvPr id="10" name="Rectangle 9"/>
+          <p:cNvSpPr/>
+          <p:nvPr/>
+        </p:nvSpPr>
+        <p:spPr>
+          <a:xfrm>
+            <a:off x="502920" y="6473952"/>
+            <a:ext cx="457200" cy="41148"/>
+          </a:xfrm>
+          <a:prstGeom prst="rect">
+            <a:avLst/>
+          </a:prstGeom>
+          <a:solidFill>
+            <a:srgbClr val="2E8C8C"/>
+          </a:solidFill>
+          <a:ln>
+            <a:noFill/>
+          </a:ln>
+          <a:effectLst/>
+        </p:spPr>
+        <p:style>
+          <a:lnRef idx="1">
+            <a:schemeClr val="accent1"/>
+          </a:lnRef>
+          <a:fillRef idx="3">
+            <a:schemeClr val="accent1"/>
+          </a:fillRef>
+          <a:effectRef idx="2">
+            <a:schemeClr val="accent1"/>
+          </a:effectRef>
+          <a:fontRef idx="minor">
+            <a:schemeClr val="lt1"/>
+          </a:fontRef>
+        </p:style>
+        <p:txBody>
+          <a:bodyPr rtlCol="0" anchor="ctr"/>
+          <a:lstStyle/>
+          <a:p>
+            <a:pPr algn="ctr"/>
+          </a:p>
+        </p:txBody>
+      </p:sp>
+      <p:sp>
+        <p:nvSpPr>
+          <p:cNvPr id="11" name="TextBox 10"/>
+          <p:cNvSpPr txBox="1"/>
+          <p:nvPr/>
+        </p:nvSpPr>
+        <p:spPr>
+          <a:xfrm>
+            <a:off x="502920" y="6108192"/>
+            <a:ext cx="2743200" cy="365760"/>
+          </a:xfrm>
+          <a:prstGeom prst="rect">
+            <a:avLst/>
+          </a:prstGeom>
+          <a:noFill/>
+        </p:spPr>
+        <p:txBody>
+          <a:bodyPr wrap="square">
+            <a:spAutoFit/>
+          </a:bodyPr>
+          <a:lstStyle/>
+          <a:p>
+            <a:pPr algn="l">
+              <a:spcAft>
+                <a:spcPts val="800"/>
+              </a:spcAft>
+            </a:pPr>
+            <a:r>
+              <a:rPr sz="1200" b="1">
+                <a:solidFill>
+                  <a:srgbClr val="2E8C8C"/>
+                </a:solidFill>
+                <a:latin typeface="Segoe UI"/>
+              </a:rPr>
+              <a:t>enjoy ⚓</a:t>
+            </a:r>
+          </a:p>
+        </p:txBody>
+      </p:sp>
+      <p:sp>
+        <p:nvSpPr>
+          <p:cNvPr id="12" name="TextBox 11"/>
+          <p:cNvSpPr txBox="1"/>
+          <p:nvPr/>
+        </p:nvSpPr>
+        <p:spPr>
+          <a:xfrm>
+            <a:off x="11155680" y="6108192"/>
+            <a:ext cx="548640" cy="365760"/>
+          </a:xfrm>
+          <a:prstGeom prst="rect">
+            <a:avLst/>
+          </a:prstGeom>
+          <a:noFill/>
+        </p:spPr>
+        <p:txBody>
+          <a:bodyPr wrap="square">
+            <a:spAutoFit/>
+          </a:bodyPr>
+          <a:lstStyle/>
+          <a:p>
+            <a:pPr algn="r">
+              <a:spcAft>
+                <a:spcPts val="800"/>
+              </a:spcAft>
+            </a:pPr>
+            <a:r>
+              <a:rPr sz="1200" b="1">
+                <a:solidFill>
+                  <a:srgbClr val="2E8C8C"/>
+                </a:solidFill>
+                <a:latin typeface="Segoe UI"/>
+              </a:rPr>
+              <a:t>02</a:t>
             </a:r>
           </a:p>
         </p:txBody>
@@ -4337,8 +4821,8 @@
         </p:nvSpPr>
         <p:spPr>
           <a:xfrm>
-            <a:off x="914400" y="1463040"/>
-            <a:ext cx="10362895" cy="3291840"/>
+            <a:off x="822960" y="502920"/>
+            <a:ext cx="5486400" cy="457200"/>
           </a:xfrm>
           <a:prstGeom prst="rect">
             <a:avLst/>
@@ -4351,51 +4835,429 @@
           </a:bodyPr>
           <a:lstStyle/>
           <a:p>
-            <a:pPr algn="ctr">
+            <a:pPr algn="l">
               <a:spcAft>
-                <a:spcPts val="1000"/>
+                <a:spcPts val="800"/>
               </a:spcAft>
             </a:pPr>
             <a:r>
-              <a:rPr sz="4000" b="1">
+              <a:rPr sz="1600" b="1">
+                <a:solidFill>
+                  <a:srgbClr val="E8B46A"/>
+                </a:solidFill>
+                <a:latin typeface="Segoe UI"/>
+              </a:rPr>
+              <a:t>WHAT WE OFFER ✅</a:t>
+            </a:r>
+          </a:p>
+        </p:txBody>
+      </p:sp>
+      <p:sp>
+        <p:nvSpPr>
+          <p:cNvPr id="3" name="TextBox 2"/>
+          <p:cNvSpPr txBox="1"/>
+          <p:nvPr/>
+        </p:nvSpPr>
+        <p:spPr>
+          <a:xfrm>
+            <a:off x="777240" y="914400"/>
+            <a:ext cx="10607040" cy="1188720"/>
+          </a:xfrm>
+          <a:prstGeom prst="rect">
+            <a:avLst/>
+          </a:prstGeom>
+          <a:noFill/>
+        </p:spPr>
+        <p:txBody>
+          <a:bodyPr wrap="square">
+            <a:spAutoFit/>
+          </a:bodyPr>
+          <a:lstStyle/>
+          <a:p>
+            <a:pPr algn="l">
+              <a:spcAft>
+                <a:spcPts val="800"/>
+              </a:spcAft>
+            </a:pPr>
+            <a:r>
+              <a:rPr sz="4400" b="1">
                 <a:solidFill>
                   <a:srgbClr val="F7F7F0"/>
                 </a:solidFill>
                 <a:latin typeface="Segoe UI"/>
               </a:rPr>
-              <a:t>What if your study plan were a harbour?</a:t>
-            </a:r>
-          </a:p>
-          <a:p>
-            <a:pPr algn="ctr">
+              <a:t>Calm automation, real learning 🌊</a:t>
+            </a:r>
+          </a:p>
+        </p:txBody>
+      </p:sp>
+      <p:sp>
+        <p:nvSpPr>
+          <p:cNvPr id="4" name="Rounded Rectangle 3"/>
+          <p:cNvSpPr/>
+          <p:nvPr/>
+        </p:nvSpPr>
+        <p:spPr>
+          <a:xfrm>
+            <a:off x="1005840" y="2331720"/>
+            <a:ext cx="10149840" cy="868680"/>
+          </a:xfrm>
+          <a:prstGeom prst="roundRect">
+            <a:avLst/>
+          </a:prstGeom>
+          <a:solidFill>
+            <a:srgbClr val="242C4E"/>
+          </a:solidFill>
+          <a:ln>
+            <a:noFill/>
+          </a:ln>
+          <a:effectLst/>
+        </p:spPr>
+        <p:style>
+          <a:lnRef idx="1">
+            <a:schemeClr val="accent1"/>
+          </a:lnRef>
+          <a:fillRef idx="3">
+            <a:schemeClr val="accent1"/>
+          </a:fillRef>
+          <a:effectRef idx="2">
+            <a:schemeClr val="accent1"/>
+          </a:effectRef>
+          <a:fontRef idx="minor">
+            <a:schemeClr val="lt1"/>
+          </a:fontRef>
+        </p:style>
+        <p:txBody>
+          <a:bodyPr rtlCol="0" anchor="ctr"/>
+          <a:lstStyle/>
+          <a:p>
+            <a:pPr algn="ctr"/>
+          </a:p>
+        </p:txBody>
+      </p:sp>
+      <p:sp>
+        <p:nvSpPr>
+          <p:cNvPr id="5" name="TextBox 4"/>
+          <p:cNvSpPr txBox="1"/>
+          <p:nvPr/>
+        </p:nvSpPr>
+        <p:spPr>
+          <a:xfrm>
+            <a:off x="1325880" y="2441448"/>
+            <a:ext cx="9509760" cy="649224"/>
+          </a:xfrm>
+          <a:prstGeom prst="rect">
+            <a:avLst/>
+          </a:prstGeom>
+          <a:noFill/>
+        </p:spPr>
+        <p:txBody>
+          <a:bodyPr wrap="square">
+            <a:spAutoFit/>
+          </a:bodyPr>
+          <a:lstStyle/>
+          <a:p>
+            <a:pPr algn="l">
               <a:spcAft>
-                <a:spcPts val="1000"/>
+                <a:spcPts val="800"/>
               </a:spcAft>
             </a:pPr>
             <a:r>
-              <a:rPr sz="2600" b="0">
+              <a:rPr sz="2400" b="0">
                 <a:solidFill>
-                  <a:srgbClr val="EDEDDD"/>
+                  <a:srgbClr val="F7F7F0"/>
                 </a:solidFill>
                 <a:latin typeface="Segoe UI"/>
               </a:rPr>
-              <a:t>tasks are boats   ·   reviews are a short sail</a:t>
-            </a:r>
-          </a:p>
-          <a:p>
-            <a:pPr algn="ctr">
+              <a:t>⏱️  time-saving AI agents  →  boring tasks gone (notes, planning)</a:t>
+            </a:r>
+          </a:p>
+        </p:txBody>
+      </p:sp>
+      <p:sp>
+        <p:nvSpPr>
+          <p:cNvPr id="6" name="Rounded Rectangle 5"/>
+          <p:cNvSpPr/>
+          <p:nvPr/>
+        </p:nvSpPr>
+        <p:spPr>
+          <a:xfrm>
+            <a:off x="1005840" y="3429000"/>
+            <a:ext cx="10149840" cy="868680"/>
+          </a:xfrm>
+          <a:prstGeom prst="roundRect">
+            <a:avLst/>
+          </a:prstGeom>
+          <a:solidFill>
+            <a:srgbClr val="242C4E"/>
+          </a:solidFill>
+          <a:ln>
+            <a:noFill/>
+          </a:ln>
+          <a:effectLst/>
+        </p:spPr>
+        <p:style>
+          <a:lnRef idx="1">
+            <a:schemeClr val="accent1"/>
+          </a:lnRef>
+          <a:fillRef idx="3">
+            <a:schemeClr val="accent1"/>
+          </a:fillRef>
+          <a:effectRef idx="2">
+            <a:schemeClr val="accent1"/>
+          </a:effectRef>
+          <a:fontRef idx="minor">
+            <a:schemeClr val="lt1"/>
+          </a:fontRef>
+        </p:style>
+        <p:txBody>
+          <a:bodyPr rtlCol="0" anchor="ctr"/>
+          <a:lstStyle/>
+          <a:p>
+            <a:pPr algn="ctr"/>
+          </a:p>
+        </p:txBody>
+      </p:sp>
+      <p:sp>
+        <p:nvSpPr>
+          <p:cNvPr id="7" name="TextBox 6"/>
+          <p:cNvSpPr txBox="1"/>
+          <p:nvPr/>
+        </p:nvSpPr>
+        <p:spPr>
+          <a:xfrm>
+            <a:off x="1325880" y="3538728"/>
+            <a:ext cx="9509760" cy="649224"/>
+          </a:xfrm>
+          <a:prstGeom prst="rect">
+            <a:avLst/>
+          </a:prstGeom>
+          <a:noFill/>
+        </p:spPr>
+        <p:txBody>
+          <a:bodyPr wrap="square">
+            <a:spAutoFit/>
+          </a:bodyPr>
+          <a:lstStyle/>
+          <a:p>
+            <a:pPr algn="l">
               <a:spcAft>
-                <a:spcPts val="1000"/>
+                <a:spcPts val="800"/>
               </a:spcAft>
             </a:pPr>
             <a:r>
-              <a:rPr sz="2600" b="0">
+              <a:rPr sz="2400" b="0">
                 <a:solidFill>
-                  <a:srgbClr val="EDEDDD"/>
+                  <a:srgbClr val="F7F7F0"/>
                 </a:solidFill>
                 <a:latin typeface="Segoe UI"/>
               </a:rPr>
-              <a:t>finished decks rest at the lamp   ·   knowledge grows as a reef below</a:t>
+              <a:t>🧩  big tasks  →  broken down  →  executive function boost</a:t>
+            </a:r>
+          </a:p>
+        </p:txBody>
+      </p:sp>
+      <p:sp>
+        <p:nvSpPr>
+          <p:cNvPr id="8" name="Rounded Rectangle 7"/>
+          <p:cNvSpPr/>
+          <p:nvPr/>
+        </p:nvSpPr>
+        <p:spPr>
+          <a:xfrm>
+            <a:off x="1005840" y="4526280"/>
+            <a:ext cx="10149840" cy="868680"/>
+          </a:xfrm>
+          <a:prstGeom prst="roundRect">
+            <a:avLst/>
+          </a:prstGeom>
+          <a:solidFill>
+            <a:srgbClr val="242C4E"/>
+          </a:solidFill>
+          <a:ln>
+            <a:noFill/>
+          </a:ln>
+          <a:effectLst/>
+        </p:spPr>
+        <p:style>
+          <a:lnRef idx="1">
+            <a:schemeClr val="accent1"/>
+          </a:lnRef>
+          <a:fillRef idx="3">
+            <a:schemeClr val="accent1"/>
+          </a:fillRef>
+          <a:effectRef idx="2">
+            <a:schemeClr val="accent1"/>
+          </a:effectRef>
+          <a:fontRef idx="minor">
+            <a:schemeClr val="lt1"/>
+          </a:fontRef>
+        </p:style>
+        <p:txBody>
+          <a:bodyPr rtlCol="0" anchor="ctr"/>
+          <a:lstStyle/>
+          <a:p>
+            <a:pPr algn="ctr"/>
+          </a:p>
+        </p:txBody>
+      </p:sp>
+      <p:sp>
+        <p:nvSpPr>
+          <p:cNvPr id="9" name="TextBox 8"/>
+          <p:cNvSpPr txBox="1"/>
+          <p:nvPr/>
+        </p:nvSpPr>
+        <p:spPr>
+          <a:xfrm>
+            <a:off x="1325880" y="4636008"/>
+            <a:ext cx="9509760" cy="649224"/>
+          </a:xfrm>
+          <a:prstGeom prst="rect">
+            <a:avLst/>
+          </a:prstGeom>
+          <a:noFill/>
+        </p:spPr>
+        <p:txBody>
+          <a:bodyPr wrap="square">
+            <a:spAutoFit/>
+          </a:bodyPr>
+          <a:lstStyle/>
+          <a:p>
+            <a:pPr algn="l">
+              <a:spcAft>
+                <a:spcPts val="800"/>
+              </a:spcAft>
+            </a:pPr>
+            <a:r>
+              <a:rPr sz="2400" b="0">
+                <a:solidFill>
+                  <a:srgbClr val="F7F7F0"/>
+                </a:solidFill>
+                <a:latin typeface="Segoe UI"/>
+              </a:rPr>
+              <a:t>🧘  psychology-backed calm  →  ❌ dashboards  ❌ red deadlines</a:t>
+            </a:r>
+          </a:p>
+        </p:txBody>
+      </p:sp>
+      <p:sp>
+        <p:nvSpPr>
+          <p:cNvPr id="10" name="Rectangle 9"/>
+          <p:cNvSpPr/>
+          <p:nvPr/>
+        </p:nvSpPr>
+        <p:spPr>
+          <a:xfrm>
+            <a:off x="502920" y="6473952"/>
+            <a:ext cx="457200" cy="41148"/>
+          </a:xfrm>
+          <a:prstGeom prst="rect">
+            <a:avLst/>
+          </a:prstGeom>
+          <a:solidFill>
+            <a:srgbClr val="D8E4E0"/>
+          </a:solidFill>
+          <a:ln>
+            <a:noFill/>
+          </a:ln>
+          <a:effectLst/>
+        </p:spPr>
+        <p:style>
+          <a:lnRef idx="1">
+            <a:schemeClr val="accent1"/>
+          </a:lnRef>
+          <a:fillRef idx="3">
+            <a:schemeClr val="accent1"/>
+          </a:fillRef>
+          <a:effectRef idx="2">
+            <a:schemeClr val="accent1"/>
+          </a:effectRef>
+          <a:fontRef idx="minor">
+            <a:schemeClr val="lt1"/>
+          </a:fontRef>
+        </p:style>
+        <p:txBody>
+          <a:bodyPr rtlCol="0" anchor="ctr"/>
+          <a:lstStyle/>
+          <a:p>
+            <a:pPr algn="ctr"/>
+          </a:p>
+        </p:txBody>
+      </p:sp>
+      <p:sp>
+        <p:nvSpPr>
+          <p:cNvPr id="11" name="TextBox 10"/>
+          <p:cNvSpPr txBox="1"/>
+          <p:nvPr/>
+        </p:nvSpPr>
+        <p:spPr>
+          <a:xfrm>
+            <a:off x="502920" y="6108192"/>
+            <a:ext cx="2743200" cy="365760"/>
+          </a:xfrm>
+          <a:prstGeom prst="rect">
+            <a:avLst/>
+          </a:prstGeom>
+          <a:noFill/>
+        </p:spPr>
+        <p:txBody>
+          <a:bodyPr wrap="square">
+            <a:spAutoFit/>
+          </a:bodyPr>
+          <a:lstStyle/>
+          <a:p>
+            <a:pPr algn="l">
+              <a:spcAft>
+                <a:spcPts val="800"/>
+              </a:spcAft>
+            </a:pPr>
+            <a:r>
+              <a:rPr sz="1200" b="1">
+                <a:solidFill>
+                  <a:srgbClr val="D8E4E0"/>
+                </a:solidFill>
+                <a:latin typeface="Segoe UI"/>
+              </a:rPr>
+              <a:t>enjoy ⚓</a:t>
+            </a:r>
+          </a:p>
+        </p:txBody>
+      </p:sp>
+      <p:sp>
+        <p:nvSpPr>
+          <p:cNvPr id="12" name="TextBox 11"/>
+          <p:cNvSpPr txBox="1"/>
+          <p:nvPr/>
+        </p:nvSpPr>
+        <p:spPr>
+          <a:xfrm>
+            <a:off x="11155680" y="6108192"/>
+            <a:ext cx="548640" cy="365760"/>
+          </a:xfrm>
+          <a:prstGeom prst="rect">
+            <a:avLst/>
+          </a:prstGeom>
+          <a:noFill/>
+        </p:spPr>
+        <p:txBody>
+          <a:bodyPr wrap="square">
+            <a:spAutoFit/>
+          </a:bodyPr>
+          <a:lstStyle/>
+          <a:p>
+            <a:pPr algn="r">
+              <a:spcAft>
+                <a:spcPts val="800"/>
+              </a:spcAft>
+            </a:pPr>
+            <a:r>
+              <a:rPr sz="1200" b="1">
+                <a:solidFill>
+                  <a:srgbClr val="D8E4E0"/>
+                </a:solidFill>
+                <a:latin typeface="Segoe UI"/>
+              </a:rPr>
+              <a:t>03</a:t>
             </a:r>
           </a:p>
         </p:txBody>
@@ -4434,8 +5296,8 @@
         </p:nvSpPr>
         <p:spPr>
           <a:xfrm>
-            <a:off x="914400" y="822960"/>
-            <a:ext cx="10362895" cy="1280160"/>
+            <a:off x="822960" y="502920"/>
+            <a:ext cx="5486400" cy="457200"/>
           </a:xfrm>
           <a:prstGeom prst="rect">
             <a:avLst/>
@@ -4448,9 +5310,48 @@
           </a:bodyPr>
           <a:lstStyle/>
           <a:p>
-            <a:pPr algn="ctr">
+            <a:pPr algn="l">
               <a:spcAft>
-                <a:spcPts val="1000"/>
+                <a:spcPts val="800"/>
+              </a:spcAft>
+            </a:pPr>
+            <a:r>
+              <a:rPr sz="1600" b="1">
+                <a:solidFill>
+                  <a:srgbClr val="E8B46A"/>
+                </a:solidFill>
+                <a:latin typeface="Segoe UI"/>
+              </a:rPr>
+              <a:t>DEMO 1/3 💬</a:t>
+            </a:r>
+          </a:p>
+        </p:txBody>
+      </p:sp>
+      <p:sp>
+        <p:nvSpPr>
+          <p:cNvPr id="3" name="TextBox 2"/>
+          <p:cNvSpPr txBox="1"/>
+          <p:nvPr/>
+        </p:nvSpPr>
+        <p:spPr>
+          <a:xfrm>
+            <a:off x="777240" y="914400"/>
+            <a:ext cx="10607040" cy="1188720"/>
+          </a:xfrm>
+          <a:prstGeom prst="rect">
+            <a:avLst/>
+          </a:prstGeom>
+          <a:noFill/>
+        </p:spPr>
+        <p:txBody>
+          <a:bodyPr wrap="square">
+            <a:spAutoFit/>
+          </a:bodyPr>
+          <a:lstStyle/>
+          <a:p>
+            <a:pPr algn="l">
+              <a:spcAft>
+                <a:spcPts val="800"/>
               </a:spcAft>
             </a:pPr>
             <a:r>
@@ -4460,21 +5361,65 @@
                 </a:solidFill>
                 <a:latin typeface="Segoe UI"/>
               </a:rPr>
-              <a:t>One sentence becomes a plan.</a:t>
-            </a:r>
-          </a:p>
-        </p:txBody>
-      </p:sp>
-      <p:sp>
-        <p:nvSpPr>
-          <p:cNvPr id="3" name="TextBox 2"/>
+              <a:t>One sentence  →  a plan 🗺️</a:t>
+            </a:r>
+          </a:p>
+        </p:txBody>
+      </p:sp>
+      <p:sp>
+        <p:nvSpPr>
+          <p:cNvPr id="4" name="Rounded Rectangle 3"/>
+          <p:cNvSpPr/>
+          <p:nvPr/>
+        </p:nvSpPr>
+        <p:spPr>
+          <a:xfrm>
+            <a:off x="1005840" y="2468880"/>
+            <a:ext cx="10149840" cy="1051560"/>
+          </a:xfrm>
+          <a:prstGeom prst="roundRect">
+            <a:avLst/>
+          </a:prstGeom>
+          <a:solidFill>
+            <a:srgbClr val="242C4E"/>
+          </a:solidFill>
+          <a:ln>
+            <a:noFill/>
+          </a:ln>
+          <a:effectLst/>
+        </p:spPr>
+        <p:style>
+          <a:lnRef idx="1">
+            <a:schemeClr val="accent1"/>
+          </a:lnRef>
+          <a:fillRef idx="3">
+            <a:schemeClr val="accent1"/>
+          </a:fillRef>
+          <a:effectRef idx="2">
+            <a:schemeClr val="accent1"/>
+          </a:effectRef>
+          <a:fontRef idx="minor">
+            <a:schemeClr val="lt1"/>
+          </a:fontRef>
+        </p:style>
+        <p:txBody>
+          <a:bodyPr rtlCol="0" anchor="ctr"/>
+          <a:lstStyle/>
+          <a:p>
+            <a:pPr algn="ctr"/>
+          </a:p>
+        </p:txBody>
+      </p:sp>
+      <p:sp>
+        <p:nvSpPr>
+          <p:cNvPr id="5" name="TextBox 4"/>
           <p:cNvSpPr txBox="1"/>
           <p:nvPr/>
         </p:nvSpPr>
         <p:spPr>
           <a:xfrm>
-            <a:off x="914400" y="2194560"/>
-            <a:ext cx="10362895" cy="1463040"/>
+            <a:off x="1325880" y="2578608"/>
+            <a:ext cx="9509760" cy="832103"/>
           </a:xfrm>
           <a:prstGeom prst="rect">
             <a:avLst/>
@@ -4487,33 +5432,49 @@
           </a:bodyPr>
           <a:lstStyle/>
           <a:p>
-            <a:pPr algn="ctr">
+            <a:pPr algn="l">
               <a:spcAft>
-                <a:spcPts val="1000"/>
+                <a:spcPts val="800"/>
               </a:spcAft>
             </a:pPr>
             <a:r>
-              <a:rPr sz="2400" b="0">
+              <a:rPr sz="2600" b="1">
+                <a:solidFill>
+                  <a:srgbClr val="E8B46A"/>
+                </a:solidFill>
+                <a:latin typeface="Segoe UI"/>
+              </a:rPr>
+              <a:t>"I have a thermodynamics exam Friday"</a:t>
+            </a:r>
+          </a:p>
+          <a:p>
+            <a:pPr algn="l">
+              <a:spcAft>
+                <a:spcPts val="800"/>
+              </a:spcAft>
+            </a:pPr>
+            <a:r>
+              <a:rPr sz="2200" b="0">
                 <a:solidFill>
                   <a:srgbClr val="EDEDDD"/>
                 </a:solidFill>
                 <a:latin typeface="Segoe UI"/>
               </a:rPr>
-              <a:t>"I have a thermodynamics exam Friday"  -&gt;  roadmap, tasks, and boats on the water</a:t>
-            </a:r>
-          </a:p>
-        </p:txBody>
-      </p:sp>
-      <p:sp>
-        <p:nvSpPr>
-          <p:cNvPr id="4" name="TextBox 3"/>
+              <a:t>→  roadmap   →  tasks   →  boats on the water ⛵</a:t>
+            </a:r>
+          </a:p>
+        </p:txBody>
+      </p:sp>
+      <p:sp>
+        <p:nvSpPr>
+          <p:cNvPr id="6" name="TextBox 5"/>
           <p:cNvSpPr txBox="1"/>
           <p:nvPr/>
         </p:nvSpPr>
         <p:spPr>
           <a:xfrm>
-            <a:off x="914400" y="4206240"/>
-            <a:ext cx="10362895" cy="1097280"/>
+            <a:off x="914400" y="4480560"/>
+            <a:ext cx="10332720" cy="822960"/>
           </a:xfrm>
           <a:prstGeom prst="rect">
             <a:avLst/>
@@ -4528,17 +5489,139 @@
           <a:p>
             <a:pPr algn="ctr">
               <a:spcAft>
-                <a:spcPts val="1000"/>
+                <a:spcPts val="800"/>
               </a:spcAft>
             </a:pPr>
             <a:r>
               <a:rPr sz="2000" b="1">
                 <a:solidFill>
-                  <a:srgbClr val="E8B46A"/>
+                  <a:srgbClr val="2E8C8C"/>
                 </a:solidFill>
                 <a:latin typeface="Segoe UI"/>
               </a:rPr>
-              <a:t>&gt;&gt;&gt; GAMEPLAY: type in chat, tour offer appears, boats spawn &lt;&lt;&lt;</a:t>
+              <a:t>▶  LIVE: type in chat  →  tour offer  →  boats spawn</a:t>
+            </a:r>
+          </a:p>
+        </p:txBody>
+      </p:sp>
+      <p:sp>
+        <p:nvSpPr>
+          <p:cNvPr id="7" name="Rectangle 6"/>
+          <p:cNvSpPr/>
+          <p:nvPr/>
+        </p:nvSpPr>
+        <p:spPr>
+          <a:xfrm>
+            <a:off x="502920" y="6473952"/>
+            <a:ext cx="457200" cy="41148"/>
+          </a:xfrm>
+          <a:prstGeom prst="rect">
+            <a:avLst/>
+          </a:prstGeom>
+          <a:solidFill>
+            <a:srgbClr val="D8E4E0"/>
+          </a:solidFill>
+          <a:ln>
+            <a:noFill/>
+          </a:ln>
+          <a:effectLst/>
+        </p:spPr>
+        <p:style>
+          <a:lnRef idx="1">
+            <a:schemeClr val="accent1"/>
+          </a:lnRef>
+          <a:fillRef idx="3">
+            <a:schemeClr val="accent1"/>
+          </a:fillRef>
+          <a:effectRef idx="2">
+            <a:schemeClr val="accent1"/>
+          </a:effectRef>
+          <a:fontRef idx="minor">
+            <a:schemeClr val="lt1"/>
+          </a:fontRef>
+        </p:style>
+        <p:txBody>
+          <a:bodyPr rtlCol="0" anchor="ctr"/>
+          <a:lstStyle/>
+          <a:p>
+            <a:pPr algn="ctr"/>
+          </a:p>
+        </p:txBody>
+      </p:sp>
+      <p:sp>
+        <p:nvSpPr>
+          <p:cNvPr id="8" name="TextBox 7"/>
+          <p:cNvSpPr txBox="1"/>
+          <p:nvPr/>
+        </p:nvSpPr>
+        <p:spPr>
+          <a:xfrm>
+            <a:off x="502920" y="6108192"/>
+            <a:ext cx="2743200" cy="365760"/>
+          </a:xfrm>
+          <a:prstGeom prst="rect">
+            <a:avLst/>
+          </a:prstGeom>
+          <a:noFill/>
+        </p:spPr>
+        <p:txBody>
+          <a:bodyPr wrap="square">
+            <a:spAutoFit/>
+          </a:bodyPr>
+          <a:lstStyle/>
+          <a:p>
+            <a:pPr algn="l">
+              <a:spcAft>
+                <a:spcPts val="800"/>
+              </a:spcAft>
+            </a:pPr>
+            <a:r>
+              <a:rPr sz="1200" b="1">
+                <a:solidFill>
+                  <a:srgbClr val="D8E4E0"/>
+                </a:solidFill>
+                <a:latin typeface="Segoe UI"/>
+              </a:rPr>
+              <a:t>enjoy ⚓</a:t>
+            </a:r>
+          </a:p>
+        </p:txBody>
+      </p:sp>
+      <p:sp>
+        <p:nvSpPr>
+          <p:cNvPr id="9" name="TextBox 8"/>
+          <p:cNvSpPr txBox="1"/>
+          <p:nvPr/>
+        </p:nvSpPr>
+        <p:spPr>
+          <a:xfrm>
+            <a:off x="11155680" y="6108192"/>
+            <a:ext cx="548640" cy="365760"/>
+          </a:xfrm>
+          <a:prstGeom prst="rect">
+            <a:avLst/>
+          </a:prstGeom>
+          <a:noFill/>
+        </p:spPr>
+        <p:txBody>
+          <a:bodyPr wrap="square">
+            <a:spAutoFit/>
+          </a:bodyPr>
+          <a:lstStyle/>
+          <a:p>
+            <a:pPr algn="r">
+              <a:spcAft>
+                <a:spcPts val="800"/>
+              </a:spcAft>
+            </a:pPr>
+            <a:r>
+              <a:rPr sz="1200" b="1">
+                <a:solidFill>
+                  <a:srgbClr val="D8E4E0"/>
+                </a:solidFill>
+                <a:latin typeface="Segoe UI"/>
+              </a:rPr>
+              <a:t>04</a:t>
             </a:r>
           </a:p>
         </p:txBody>
@@ -4577,8 +5660,8 @@
         </p:nvSpPr>
         <p:spPr>
           <a:xfrm>
-            <a:off x="914400" y="822960"/>
-            <a:ext cx="10362895" cy="1280160"/>
+            <a:off x="822960" y="502920"/>
+            <a:ext cx="5486400" cy="457200"/>
           </a:xfrm>
           <a:prstGeom prst="rect">
             <a:avLst/>
@@ -4591,9 +5674,48 @@
           </a:bodyPr>
           <a:lstStyle/>
           <a:p>
-            <a:pPr algn="ctr">
+            <a:pPr algn="l">
               <a:spcAft>
-                <a:spcPts val="1000"/>
+                <a:spcPts val="800"/>
+              </a:spcAft>
+            </a:pPr>
+            <a:r>
+              <a:rPr sz="1600" b="1">
+                <a:solidFill>
+                  <a:srgbClr val="1A203B"/>
+                </a:solidFill>
+                <a:latin typeface="Segoe UI"/>
+              </a:rPr>
+              <a:t>DEMO 2/3 ⛵</a:t>
+            </a:r>
+          </a:p>
+        </p:txBody>
+      </p:sp>
+      <p:sp>
+        <p:nvSpPr>
+          <p:cNvPr id="3" name="TextBox 2"/>
+          <p:cNvSpPr txBox="1"/>
+          <p:nvPr/>
+        </p:nvSpPr>
+        <p:spPr>
+          <a:xfrm>
+            <a:off x="777240" y="914400"/>
+            <a:ext cx="10607040" cy="1188720"/>
+          </a:xfrm>
+          <a:prstGeom prst="rect">
+            <a:avLst/>
+          </a:prstGeom>
+          <a:noFill/>
+        </p:spPr>
+        <p:txBody>
+          <a:bodyPr wrap="square">
+            <a:spAutoFit/>
+          </a:bodyPr>
+          <a:lstStyle/>
+          <a:p>
+            <a:pPr algn="l">
+              <a:spcAft>
+                <a:spcPts val="800"/>
               </a:spcAft>
             </a:pPr>
             <a:r>
@@ -4603,21 +5725,65 @@
                 </a:solidFill>
                 <a:latin typeface="Segoe UI"/>
               </a:rPr>
-              <a:t>Flashcards are a short sail.</a:t>
-            </a:r>
-          </a:p>
-        </p:txBody>
-      </p:sp>
-      <p:sp>
-        <p:nvSpPr>
-          <p:cNvPr id="3" name="TextBox 2"/>
+              <a:t>Flashcards  =  a short sail 🃏</a:t>
+            </a:r>
+          </a:p>
+        </p:txBody>
+      </p:sp>
+      <p:sp>
+        <p:nvSpPr>
+          <p:cNvPr id="4" name="Rounded Rectangle 3"/>
+          <p:cNvSpPr/>
+          <p:nvPr/>
+        </p:nvSpPr>
+        <p:spPr>
+          <a:xfrm>
+            <a:off x="1005840" y="2377440"/>
+            <a:ext cx="10149840" cy="1554480"/>
+          </a:xfrm>
+          <a:prstGeom prst="roundRect">
+            <a:avLst/>
+          </a:prstGeom>
+          <a:solidFill>
+            <a:srgbClr val="242C4E"/>
+          </a:solidFill>
+          <a:ln>
+            <a:noFill/>
+          </a:ln>
+          <a:effectLst/>
+        </p:spPr>
+        <p:style>
+          <a:lnRef idx="1">
+            <a:schemeClr val="accent1"/>
+          </a:lnRef>
+          <a:fillRef idx="3">
+            <a:schemeClr val="accent1"/>
+          </a:fillRef>
+          <a:effectRef idx="2">
+            <a:schemeClr val="accent1"/>
+          </a:effectRef>
+          <a:fontRef idx="minor">
+            <a:schemeClr val="lt1"/>
+          </a:fontRef>
+        </p:style>
+        <p:txBody>
+          <a:bodyPr rtlCol="0" anchor="ctr"/>
+          <a:lstStyle/>
+          <a:p>
+            <a:pPr algn="ctr"/>
+          </a:p>
+        </p:txBody>
+      </p:sp>
+      <p:sp>
+        <p:nvSpPr>
+          <p:cNvPr id="5" name="TextBox 4"/>
           <p:cNvSpPr txBox="1"/>
           <p:nvPr/>
         </p:nvSpPr>
         <p:spPr>
           <a:xfrm>
-            <a:off x="914400" y="2194560"/>
-            <a:ext cx="10362895" cy="1828800"/>
+            <a:off x="1325880" y="2487168"/>
+            <a:ext cx="9509760" cy="1335024"/>
           </a:xfrm>
           <a:prstGeom prst="rect">
             <a:avLst/>
@@ -4630,49 +5796,49 @@
           </a:bodyPr>
           <a:lstStyle/>
           <a:p>
-            <a:pPr algn="ctr">
+            <a:pPr algn="l">
               <a:spcAft>
-                <a:spcPts val="1000"/>
+                <a:spcPts val="800"/>
               </a:spcAft>
             </a:pPr>
             <a:r>
-              <a:rPr sz="2400" b="0">
+              <a:rPr sz="2600" b="1">
                 <a:solidFill>
                   <a:srgbClr val="F7F7F0"/>
                 </a:solidFill>
                 <a:latin typeface="Segoe UI"/>
               </a:rPr>
-              <a:t>board the boat  -&gt;  question  -&gt;  reveal  -&gt;  four grade boats</a:t>
-            </a:r>
-          </a:p>
-          <a:p>
-            <a:pPr algn="ctr">
+              <a:t>board  →  ❓ question  →  👀 reveal  →  4️⃣ grade boats</a:t>
+            </a:r>
+          </a:p>
+          <a:p>
+            <a:pPr algn="l">
               <a:spcAft>
-                <a:spcPts val="1000"/>
+                <a:spcPts val="800"/>
               </a:spcAft>
             </a:pPr>
             <a:r>
-              <a:rPr sz="2400" b="0">
+              <a:rPr sz="2200" b="0">
                 <a:solidFill>
                   <a:srgbClr val="EDEDDD"/>
                 </a:solidFill>
                 <a:latin typeface="Segoe UI"/>
               </a:rPr>
-              <a:t>finish the deck and it docks at the lamp — glowing a little brighter</a:t>
-            </a:r>
-          </a:p>
-        </p:txBody>
-      </p:sp>
-      <p:sp>
-        <p:nvSpPr>
-          <p:cNvPr id="4" name="TextBox 3"/>
+              <a:t>deck done  →  docks at the lamp  →  glows brighter 🏮✨</a:t>
+            </a:r>
+          </a:p>
+        </p:txBody>
+      </p:sp>
+      <p:sp>
+        <p:nvSpPr>
+          <p:cNvPr id="6" name="TextBox 5"/>
           <p:cNvSpPr txBox="1"/>
           <p:nvPr/>
         </p:nvSpPr>
         <p:spPr>
           <a:xfrm>
             <a:off x="914400" y="4480560"/>
-            <a:ext cx="10362895" cy="1097280"/>
+            <a:ext cx="10332720" cy="822960"/>
           </a:xfrm>
           <a:prstGeom prst="rect">
             <a:avLst/>
@@ -4687,7 +5853,7 @@
           <a:p>
             <a:pPr algn="ctr">
               <a:spcAft>
-                <a:spcPts val="1000"/>
+                <a:spcPts val="800"/>
               </a:spcAft>
             </a:pPr>
             <a:r>
@@ -4697,7 +5863,129 @@
                 </a:solidFill>
                 <a:latin typeface="Segoe UI"/>
               </a:rPr>
-              <a:t>&gt;&gt;&gt; GAMEPLAY: full 3-card review, keyboard only, dock + lamp glow &lt;&lt;&lt;</a:t>
+              <a:t>▶  LIVE: 3-card review, keyboard only, dock + lamp glow</a:t>
+            </a:r>
+          </a:p>
+        </p:txBody>
+      </p:sp>
+      <p:sp>
+        <p:nvSpPr>
+          <p:cNvPr id="7" name="Rectangle 6"/>
+          <p:cNvSpPr/>
+          <p:nvPr/>
+        </p:nvSpPr>
+        <p:spPr>
+          <a:xfrm>
+            <a:off x="502920" y="6473952"/>
+            <a:ext cx="457200" cy="41148"/>
+          </a:xfrm>
+          <a:prstGeom prst="rect">
+            <a:avLst/>
+          </a:prstGeom>
+          <a:solidFill>
+            <a:srgbClr val="D8E4E0"/>
+          </a:solidFill>
+          <a:ln>
+            <a:noFill/>
+          </a:ln>
+          <a:effectLst/>
+        </p:spPr>
+        <p:style>
+          <a:lnRef idx="1">
+            <a:schemeClr val="accent1"/>
+          </a:lnRef>
+          <a:fillRef idx="3">
+            <a:schemeClr val="accent1"/>
+          </a:fillRef>
+          <a:effectRef idx="2">
+            <a:schemeClr val="accent1"/>
+          </a:effectRef>
+          <a:fontRef idx="minor">
+            <a:schemeClr val="lt1"/>
+          </a:fontRef>
+        </p:style>
+        <p:txBody>
+          <a:bodyPr rtlCol="0" anchor="ctr"/>
+          <a:lstStyle/>
+          <a:p>
+            <a:pPr algn="ctr"/>
+          </a:p>
+        </p:txBody>
+      </p:sp>
+      <p:sp>
+        <p:nvSpPr>
+          <p:cNvPr id="8" name="TextBox 7"/>
+          <p:cNvSpPr txBox="1"/>
+          <p:nvPr/>
+        </p:nvSpPr>
+        <p:spPr>
+          <a:xfrm>
+            <a:off x="502920" y="6108192"/>
+            <a:ext cx="2743200" cy="365760"/>
+          </a:xfrm>
+          <a:prstGeom prst="rect">
+            <a:avLst/>
+          </a:prstGeom>
+          <a:noFill/>
+        </p:spPr>
+        <p:txBody>
+          <a:bodyPr wrap="square">
+            <a:spAutoFit/>
+          </a:bodyPr>
+          <a:lstStyle/>
+          <a:p>
+            <a:pPr algn="l">
+              <a:spcAft>
+                <a:spcPts val="800"/>
+              </a:spcAft>
+            </a:pPr>
+            <a:r>
+              <a:rPr sz="1200" b="1">
+                <a:solidFill>
+                  <a:srgbClr val="D8E4E0"/>
+                </a:solidFill>
+                <a:latin typeface="Segoe UI"/>
+              </a:rPr>
+              <a:t>enjoy ⚓</a:t>
+            </a:r>
+          </a:p>
+        </p:txBody>
+      </p:sp>
+      <p:sp>
+        <p:nvSpPr>
+          <p:cNvPr id="9" name="TextBox 8"/>
+          <p:cNvSpPr txBox="1"/>
+          <p:nvPr/>
+        </p:nvSpPr>
+        <p:spPr>
+          <a:xfrm>
+            <a:off x="11155680" y="6108192"/>
+            <a:ext cx="548640" cy="365760"/>
+          </a:xfrm>
+          <a:prstGeom prst="rect">
+            <a:avLst/>
+          </a:prstGeom>
+          <a:noFill/>
+        </p:spPr>
+        <p:txBody>
+          <a:bodyPr wrap="square">
+            <a:spAutoFit/>
+          </a:bodyPr>
+          <a:lstStyle/>
+          <a:p>
+            <a:pPr algn="r">
+              <a:spcAft>
+                <a:spcPts val="800"/>
+              </a:spcAft>
+            </a:pPr>
+            <a:r>
+              <a:rPr sz="1200" b="1">
+                <a:solidFill>
+                  <a:srgbClr val="D8E4E0"/>
+                </a:solidFill>
+                <a:latin typeface="Segoe UI"/>
+              </a:rPr>
+              <a:t>05</a:t>
             </a:r>
           </a:p>
         </p:txBody>
@@ -4736,8 +6024,8 @@
         </p:nvSpPr>
         <p:spPr>
           <a:xfrm>
-            <a:off x="914400" y="822960"/>
-            <a:ext cx="10362895" cy="1280160"/>
+            <a:off x="822960" y="502920"/>
+            <a:ext cx="5486400" cy="457200"/>
           </a:xfrm>
           <a:prstGeom prst="rect">
             <a:avLst/>
@@ -4750,9 +6038,48 @@
           </a:bodyPr>
           <a:lstStyle/>
           <a:p>
-            <a:pPr algn="ctr">
+            <a:pPr algn="l">
               <a:spcAft>
-                <a:spcPts val="1000"/>
+                <a:spcPts val="800"/>
+              </a:spcAft>
+            </a:pPr>
+            <a:r>
+              <a:rPr sz="1600" b="1">
+                <a:solidFill>
+                  <a:srgbClr val="E8B46A"/>
+                </a:solidFill>
+                <a:latin typeface="Segoe UI"/>
+              </a:rPr>
+              <a:t>DEMO 3/3 🫧</a:t>
+            </a:r>
+          </a:p>
+        </p:txBody>
+      </p:sp>
+      <p:sp>
+        <p:nvSpPr>
+          <p:cNvPr id="3" name="TextBox 2"/>
+          <p:cNvSpPr txBox="1"/>
+          <p:nvPr/>
+        </p:nvSpPr>
+        <p:spPr>
+          <a:xfrm>
+            <a:off x="777240" y="914400"/>
+            <a:ext cx="10607040" cy="1188720"/>
+          </a:xfrm>
+          <a:prstGeom prst="rect">
+            <a:avLst/>
+          </a:prstGeom>
+          <a:noFill/>
+        </p:spPr>
+        <p:txBody>
+          <a:bodyPr wrap="square">
+            <a:spAutoFit/>
+          </a:bodyPr>
+          <a:lstStyle/>
+          <a:p>
+            <a:pPr algn="l">
+              <a:spcAft>
+                <a:spcPts val="800"/>
               </a:spcAft>
             </a:pPr>
             <a:r>
@@ -4762,21 +6089,65 @@
                 </a:solidFill>
                 <a:latin typeface="Segoe UI"/>
               </a:rPr>
-              <a:t>Knowledge grows beneath the sea.</a:t>
-            </a:r>
-          </a:p>
-        </p:txBody>
-      </p:sp>
-      <p:sp>
-        <p:nvSpPr>
-          <p:cNvPr id="3" name="TextBox 2"/>
+              <a:t>Knowledge grows under the sea 🪸</a:t>
+            </a:r>
+          </a:p>
+        </p:txBody>
+      </p:sp>
+      <p:sp>
+        <p:nvSpPr>
+          <p:cNvPr id="4" name="Rounded Rectangle 3"/>
+          <p:cNvSpPr/>
+          <p:nvPr/>
+        </p:nvSpPr>
+        <p:spPr>
+          <a:xfrm>
+            <a:off x="1005840" y="2468880"/>
+            <a:ext cx="10149840" cy="1051560"/>
+          </a:xfrm>
+          <a:prstGeom prst="roundRect">
+            <a:avLst/>
+          </a:prstGeom>
+          <a:solidFill>
+            <a:srgbClr val="242C4E"/>
+          </a:solidFill>
+          <a:ln>
+            <a:noFill/>
+          </a:ln>
+          <a:effectLst/>
+        </p:spPr>
+        <p:style>
+          <a:lnRef idx="1">
+            <a:schemeClr val="accent1"/>
+          </a:lnRef>
+          <a:fillRef idx="3">
+            <a:schemeClr val="accent1"/>
+          </a:fillRef>
+          <a:effectRef idx="2">
+            <a:schemeClr val="accent1"/>
+          </a:effectRef>
+          <a:fontRef idx="minor">
+            <a:schemeClr val="lt1"/>
+          </a:fontRef>
+        </p:style>
+        <p:txBody>
+          <a:bodyPr rtlCol="0" anchor="ctr"/>
+          <a:lstStyle/>
+          <a:p>
+            <a:pPr algn="ctr"/>
+          </a:p>
+        </p:txBody>
+      </p:sp>
+      <p:sp>
+        <p:nvSpPr>
+          <p:cNvPr id="5" name="TextBox 4"/>
           <p:cNvSpPr txBox="1"/>
           <p:nvPr/>
         </p:nvSpPr>
         <p:spPr>
           <a:xfrm>
-            <a:off x="914400" y="2194560"/>
-            <a:ext cx="10362895" cy="1463040"/>
+            <a:off x="1325880" y="2578608"/>
+            <a:ext cx="9509760" cy="832103"/>
           </a:xfrm>
           <a:prstGeom prst="rect">
             <a:avLst/>
@@ -4789,33 +6160,49 @@
           </a:bodyPr>
           <a:lstStyle/>
           <a:p>
-            <a:pPr algn="ctr">
+            <a:pPr algn="l">
               <a:spcAft>
-                <a:spcPts val="1000"/>
+                <a:spcPts val="800"/>
               </a:spcAft>
             </a:pPr>
             <a:r>
               <a:rPr sz="2400" b="0">
+                <a:solidFill>
+                  <a:srgbClr val="F7F7F0"/>
+                </a:solidFill>
+                <a:latin typeface="Segoe UI"/>
+              </a:rPr>
+              <a:t>dive down 🤿  →  every concept joins a living atlas</a:t>
+            </a:r>
+          </a:p>
+          <a:p>
+            <a:pPr algn="l">
+              <a:spcAft>
+                <a:spcPts val="800"/>
+              </a:spcAft>
+            </a:pPr>
+            <a:r>
+              <a:rPr sz="2200" b="0">
                 <a:solidFill>
                   <a:srgbClr val="EDEDDD"/>
                 </a:solidFill>
                 <a:latin typeface="Segoe UI"/>
               </a:rPr>
-              <a:t>dive down: every concept you study joins a living atlas</a:t>
-            </a:r>
-          </a:p>
-        </p:txBody>
-      </p:sp>
-      <p:sp>
-        <p:nvSpPr>
-          <p:cNvPr id="4" name="TextBox 3"/>
+              <a:t>your portfolio isn't a chart  →  it's a place</a:t>
+            </a:r>
+          </a:p>
+        </p:txBody>
+      </p:sp>
+      <p:sp>
+        <p:nvSpPr>
+          <p:cNvPr id="6" name="TextBox 5"/>
           <p:cNvSpPr txBox="1"/>
           <p:nvPr/>
         </p:nvSpPr>
         <p:spPr>
           <a:xfrm>
-            <a:off x="914400" y="4206240"/>
-            <a:ext cx="10362895" cy="1097280"/>
+            <a:off x="914400" y="4480560"/>
+            <a:ext cx="10332720" cy="822960"/>
           </a:xfrm>
           <a:prstGeom prst="rect">
             <a:avLst/>
@@ -4830,17 +6217,139 @@
           <a:p>
             <a:pPr algn="ctr">
               <a:spcAft>
-                <a:spcPts val="1000"/>
+                <a:spcPts val="800"/>
               </a:spcAft>
             </a:pPr>
             <a:r>
               <a:rPr sz="2000" b="1">
                 <a:solidFill>
-                  <a:srgbClr val="E8B46A"/>
+                  <a:srgbClr val="2E8C8C"/>
                 </a:solidFill>
                 <a:latin typeface="Segoe UI"/>
               </a:rPr>
-              <a:t>&gt;&gt;&gt; GAMEPLAY: dive transition, atlas nodes, click a node &lt;&lt;&lt;</a:t>
+              <a:t>▶  LIVE: dive transition  →  atlas  →  click a node</a:t>
+            </a:r>
+          </a:p>
+        </p:txBody>
+      </p:sp>
+      <p:sp>
+        <p:nvSpPr>
+          <p:cNvPr id="7" name="Rectangle 6"/>
+          <p:cNvSpPr/>
+          <p:nvPr/>
+        </p:nvSpPr>
+        <p:spPr>
+          <a:xfrm>
+            <a:off x="502920" y="6473952"/>
+            <a:ext cx="457200" cy="41148"/>
+          </a:xfrm>
+          <a:prstGeom prst="rect">
+            <a:avLst/>
+          </a:prstGeom>
+          <a:solidFill>
+            <a:srgbClr val="D8E4E0"/>
+          </a:solidFill>
+          <a:ln>
+            <a:noFill/>
+          </a:ln>
+          <a:effectLst/>
+        </p:spPr>
+        <p:style>
+          <a:lnRef idx="1">
+            <a:schemeClr val="accent1"/>
+          </a:lnRef>
+          <a:fillRef idx="3">
+            <a:schemeClr val="accent1"/>
+          </a:fillRef>
+          <a:effectRef idx="2">
+            <a:schemeClr val="accent1"/>
+          </a:effectRef>
+          <a:fontRef idx="minor">
+            <a:schemeClr val="lt1"/>
+          </a:fontRef>
+        </p:style>
+        <p:txBody>
+          <a:bodyPr rtlCol="0" anchor="ctr"/>
+          <a:lstStyle/>
+          <a:p>
+            <a:pPr algn="ctr"/>
+          </a:p>
+        </p:txBody>
+      </p:sp>
+      <p:sp>
+        <p:nvSpPr>
+          <p:cNvPr id="8" name="TextBox 7"/>
+          <p:cNvSpPr txBox="1"/>
+          <p:nvPr/>
+        </p:nvSpPr>
+        <p:spPr>
+          <a:xfrm>
+            <a:off x="502920" y="6108192"/>
+            <a:ext cx="2743200" cy="365760"/>
+          </a:xfrm>
+          <a:prstGeom prst="rect">
+            <a:avLst/>
+          </a:prstGeom>
+          <a:noFill/>
+        </p:spPr>
+        <p:txBody>
+          <a:bodyPr wrap="square">
+            <a:spAutoFit/>
+          </a:bodyPr>
+          <a:lstStyle/>
+          <a:p>
+            <a:pPr algn="l">
+              <a:spcAft>
+                <a:spcPts val="800"/>
+              </a:spcAft>
+            </a:pPr>
+            <a:r>
+              <a:rPr sz="1200" b="1">
+                <a:solidFill>
+                  <a:srgbClr val="D8E4E0"/>
+                </a:solidFill>
+                <a:latin typeface="Segoe UI"/>
+              </a:rPr>
+              <a:t>enjoy ⚓</a:t>
+            </a:r>
+          </a:p>
+        </p:txBody>
+      </p:sp>
+      <p:sp>
+        <p:nvSpPr>
+          <p:cNvPr id="9" name="TextBox 8"/>
+          <p:cNvSpPr txBox="1"/>
+          <p:nvPr/>
+        </p:nvSpPr>
+        <p:spPr>
+          <a:xfrm>
+            <a:off x="11155680" y="6108192"/>
+            <a:ext cx="548640" cy="365760"/>
+          </a:xfrm>
+          <a:prstGeom prst="rect">
+            <a:avLst/>
+          </a:prstGeom>
+          <a:noFill/>
+        </p:spPr>
+        <p:txBody>
+          <a:bodyPr wrap="square">
+            <a:spAutoFit/>
+          </a:bodyPr>
+          <a:lstStyle/>
+          <a:p>
+            <a:pPr algn="r">
+              <a:spcAft>
+                <a:spcPts val="800"/>
+              </a:spcAft>
+            </a:pPr>
+            <a:r>
+              <a:rPr sz="1200" b="1">
+                <a:solidFill>
+                  <a:srgbClr val="D8E4E0"/>
+                </a:solidFill>
+                <a:latin typeface="Segoe UI"/>
+              </a:rPr>
+              <a:t>06</a:t>
             </a:r>
           </a:p>
         </p:txBody>
@@ -4879,8 +6388,8 @@
         </p:nvSpPr>
         <p:spPr>
           <a:xfrm>
-            <a:off x="914400" y="731520"/>
-            <a:ext cx="10362895" cy="914400"/>
+            <a:off x="822960" y="502920"/>
+            <a:ext cx="5486400" cy="457200"/>
           </a:xfrm>
           <a:prstGeom prst="rect">
             <a:avLst/>
@@ -4893,33 +6402,116 @@
           </a:bodyPr>
           <a:lstStyle/>
           <a:p>
-            <a:pPr algn="ctr">
+            <a:pPr algn="l">
               <a:spcAft>
-                <a:spcPts val="1000"/>
+                <a:spcPts val="800"/>
               </a:spcAft>
             </a:pPr>
             <a:r>
-              <a:rPr sz="4000" b="1">
+              <a:rPr sz="1600" b="1">
+                <a:solidFill>
+                  <a:srgbClr val="0F4C5C"/>
+                </a:solidFill>
+                <a:latin typeface="Segoe UI"/>
+              </a:rPr>
+              <a:t>UNDER THE HOOD ⚙️</a:t>
+            </a:r>
+          </a:p>
+        </p:txBody>
+      </p:sp>
+      <p:sp>
+        <p:nvSpPr>
+          <p:cNvPr id="3" name="TextBox 2"/>
+          <p:cNvSpPr txBox="1"/>
+          <p:nvPr/>
+        </p:nvSpPr>
+        <p:spPr>
+          <a:xfrm>
+            <a:off x="777240" y="914400"/>
+            <a:ext cx="10607040" cy="1188720"/>
+          </a:xfrm>
+          <a:prstGeom prst="rect">
+            <a:avLst/>
+          </a:prstGeom>
+          <a:noFill/>
+        </p:spPr>
+        <p:txBody>
+          <a:bodyPr wrap="square">
+            <a:spAutoFit/>
+          </a:bodyPr>
+          <a:lstStyle/>
+          <a:p>
+            <a:pPr algn="l">
+              <a:spcAft>
+                <a:spcPts val="800"/>
+              </a:spcAft>
+            </a:pPr>
+            <a:r>
+              <a:rPr sz="4400" b="1">
                 <a:solidFill>
                   <a:srgbClr val="1A203B"/>
                 </a:solidFill>
                 <a:latin typeface="Segoe UI"/>
               </a:rPr>
-              <a:t>Under the hood</a:t>
-            </a:r>
-          </a:p>
-        </p:txBody>
-      </p:sp>
-      <p:sp>
-        <p:nvSpPr>
-          <p:cNvPr id="3" name="TextBox 2"/>
+              <a:t>Built to be trusted 🔧</a:t>
+            </a:r>
+          </a:p>
+        </p:txBody>
+      </p:sp>
+      <p:sp>
+        <p:nvSpPr>
+          <p:cNvPr id="4" name="Rounded Rectangle 3"/>
+          <p:cNvSpPr/>
+          <p:nvPr/>
+        </p:nvSpPr>
+        <p:spPr>
+          <a:xfrm>
+            <a:off x="1005840" y="2286000"/>
+            <a:ext cx="10149840" cy="822960"/>
+          </a:xfrm>
+          <a:prstGeom prst="roundRect">
+            <a:avLst/>
+          </a:prstGeom>
+          <a:solidFill>
+            <a:srgbClr val="FFFFF8"/>
+          </a:solidFill>
+          <a:ln>
+            <a:noFill/>
+          </a:ln>
+          <a:effectLst/>
+        </p:spPr>
+        <p:style>
+          <a:lnRef idx="1">
+            <a:schemeClr val="accent1"/>
+          </a:lnRef>
+          <a:fillRef idx="3">
+            <a:schemeClr val="accent1"/>
+          </a:fillRef>
+          <a:effectRef idx="2">
+            <a:schemeClr val="accent1"/>
+          </a:effectRef>
+          <a:fontRef idx="minor">
+            <a:schemeClr val="lt1"/>
+          </a:fontRef>
+        </p:style>
+        <p:txBody>
+          <a:bodyPr rtlCol="0" anchor="ctr"/>
+          <a:lstStyle/>
+          <a:p>
+            <a:pPr algn="ctr"/>
+          </a:p>
+        </p:txBody>
+      </p:sp>
+      <p:sp>
+        <p:nvSpPr>
+          <p:cNvPr id="5" name="TextBox 4"/>
           <p:cNvSpPr txBox="1"/>
           <p:nvPr/>
         </p:nvSpPr>
         <p:spPr>
           <a:xfrm>
-            <a:off x="1280160" y="1920240"/>
-            <a:ext cx="9601200" cy="3840480"/>
+            <a:off x="1325880" y="2395728"/>
+            <a:ext cx="9509760" cy="603504"/>
           </a:xfrm>
           <a:prstGeom prst="rect">
             <a:avLst/>
@@ -4934,55 +6526,212 @@
           <a:p>
             <a:pPr algn="l">
               <a:spcAft>
-                <a:spcPts val="1000"/>
+                <a:spcPts val="800"/>
               </a:spcAft>
             </a:pPr>
             <a:r>
-              <a:rPr sz="2400" b="0">
+              <a:rPr sz="2200" b="0">
                 <a:solidFill>
                   <a:srgbClr val="1A203B"/>
                 </a:solidFill>
                 <a:latin typeface="Segoe UI"/>
               </a:rPr>
-              <a:t>FastAPI + agent orchestrator  -&gt;  planner, flashcards, knowledge graph</a:t>
-            </a:r>
-          </a:p>
+              <a:t>🧠  FastAPI + agent orchestrator  →  planner · flashcards · graph</a:t>
+            </a:r>
+          </a:p>
+        </p:txBody>
+      </p:sp>
+      <p:sp>
+        <p:nvSpPr>
+          <p:cNvPr id="6" name="Rounded Rectangle 5"/>
+          <p:cNvSpPr/>
+          <p:nvPr/>
+        </p:nvSpPr>
+        <p:spPr>
+          <a:xfrm>
+            <a:off x="1005840" y="3310128"/>
+            <a:ext cx="10149840" cy="822960"/>
+          </a:xfrm>
+          <a:prstGeom prst="roundRect">
+            <a:avLst/>
+          </a:prstGeom>
+          <a:solidFill>
+            <a:srgbClr val="FFFFF8"/>
+          </a:solidFill>
+          <a:ln>
+            <a:noFill/>
+          </a:ln>
+          <a:effectLst/>
+        </p:spPr>
+        <p:style>
+          <a:lnRef idx="1">
+            <a:schemeClr val="accent1"/>
+          </a:lnRef>
+          <a:fillRef idx="3">
+            <a:schemeClr val="accent1"/>
+          </a:fillRef>
+          <a:effectRef idx="2">
+            <a:schemeClr val="accent1"/>
+          </a:effectRef>
+          <a:fontRef idx="minor">
+            <a:schemeClr val="lt1"/>
+          </a:fontRef>
+        </p:style>
+        <p:txBody>
+          <a:bodyPr rtlCol="0" anchor="ctr"/>
+          <a:lstStyle/>
+          <a:p>
+            <a:pPr algn="ctr"/>
+          </a:p>
+        </p:txBody>
+      </p:sp>
+      <p:sp>
+        <p:nvSpPr>
+          <p:cNvPr id="7" name="TextBox 6"/>
+          <p:cNvSpPr txBox="1"/>
+          <p:nvPr/>
+        </p:nvSpPr>
+        <p:spPr>
+          <a:xfrm>
+            <a:off x="1325880" y="3419856"/>
+            <a:ext cx="9509760" cy="603504"/>
+          </a:xfrm>
+          <a:prstGeom prst="rect">
+            <a:avLst/>
+          </a:prstGeom>
+          <a:noFill/>
+        </p:spPr>
+        <p:txBody>
+          <a:bodyPr wrap="square">
+            <a:spAutoFit/>
+          </a:bodyPr>
+          <a:lstStyle/>
           <a:p>
             <a:pPr algn="l">
               <a:spcAft>
-                <a:spcPts val="1000"/>
+                <a:spcPts val="800"/>
               </a:spcAft>
             </a:pPr>
             <a:r>
-              <a:rPr sz="2400" b="0">
+              <a:rPr sz="2200" b="0">
                 <a:solidFill>
                   <a:srgbClr val="1A203B"/>
                 </a:solidFill>
                 <a:latin typeface="Segoe UI"/>
               </a:rPr>
-              <a:t>Postgres + one ordered event stream  -&gt;  the world can never drift</a:t>
-            </a:r>
-          </a:p>
+              <a:t>🗄️  Postgres + one ordered event stream  →  world never drifts</a:t>
+            </a:r>
+          </a:p>
+        </p:txBody>
+      </p:sp>
+      <p:sp>
+        <p:nvSpPr>
+          <p:cNvPr id="8" name="Rounded Rectangle 7"/>
+          <p:cNvSpPr/>
+          <p:nvPr/>
+        </p:nvSpPr>
+        <p:spPr>
+          <a:xfrm>
+            <a:off x="1005840" y="4334256"/>
+            <a:ext cx="10149840" cy="822960"/>
+          </a:xfrm>
+          <a:prstGeom prst="roundRect">
+            <a:avLst/>
+          </a:prstGeom>
+          <a:solidFill>
+            <a:srgbClr val="FFFFF8"/>
+          </a:solidFill>
+          <a:ln>
+            <a:noFill/>
+          </a:ln>
+          <a:effectLst/>
+        </p:spPr>
+        <p:style>
+          <a:lnRef idx="1">
+            <a:schemeClr val="accent1"/>
+          </a:lnRef>
+          <a:fillRef idx="3">
+            <a:schemeClr val="accent1"/>
+          </a:fillRef>
+          <a:effectRef idx="2">
+            <a:schemeClr val="accent1"/>
+          </a:effectRef>
+          <a:fontRef idx="minor">
+            <a:schemeClr val="lt1"/>
+          </a:fontRef>
+        </p:style>
+        <p:txBody>
+          <a:bodyPr rtlCol="0" anchor="ctr"/>
+          <a:lstStyle/>
+          <a:p>
+            <a:pPr algn="ctr"/>
+          </a:p>
+        </p:txBody>
+      </p:sp>
+      <p:sp>
+        <p:nvSpPr>
+          <p:cNvPr id="9" name="TextBox 8"/>
+          <p:cNvSpPr txBox="1"/>
+          <p:nvPr/>
+        </p:nvSpPr>
+        <p:spPr>
+          <a:xfrm>
+            <a:off x="1325880" y="4443984"/>
+            <a:ext cx="9509760" cy="603504"/>
+          </a:xfrm>
+          <a:prstGeom prst="rect">
+            <a:avLst/>
+          </a:prstGeom>
+          <a:noFill/>
+        </p:spPr>
+        <p:txBody>
+          <a:bodyPr wrap="square">
+            <a:spAutoFit/>
+          </a:bodyPr>
+          <a:lstStyle/>
           <a:p>
             <a:pPr algn="l">
               <a:spcAft>
-                <a:spcPts val="1000"/>
+                <a:spcPts val="800"/>
               </a:spcAft>
             </a:pPr>
             <a:r>
-              <a:rPr sz="2400" b="0">
+              <a:rPr sz="2200" b="0">
                 <a:solidFill>
                   <a:srgbClr val="1A203B"/>
                 </a:solidFill>
                 <a:latin typeface="Segoe UI"/>
               </a:rPr>
-              <a:t>Next.js + three.js  -&gt;  one runtime path, no mock modes</a:t>
-            </a:r>
-          </a:p>
-          <a:p>
-            <a:pPr algn="l">
+              <a:t>🕸️  Next.js + three.js  →  one runtime path, no mock modes</a:t>
+            </a:r>
+          </a:p>
+        </p:txBody>
+      </p:sp>
+      <p:sp>
+        <p:nvSpPr>
+          <p:cNvPr id="10" name="TextBox 9"/>
+          <p:cNvSpPr txBox="1"/>
+          <p:nvPr/>
+        </p:nvSpPr>
+        <p:spPr>
+          <a:xfrm>
+            <a:off x="914400" y="5486400"/>
+            <a:ext cx="10332720" cy="640080"/>
+          </a:xfrm>
+          <a:prstGeom prst="rect">
+            <a:avLst/>
+          </a:prstGeom>
+          <a:noFill/>
+        </p:spPr>
+        <p:txBody>
+          <a:bodyPr wrap="square">
+            <a:spAutoFit/>
+          </a:bodyPr>
+          <a:lstStyle/>
+          <a:p>
+            <a:pPr algn="ctr">
               <a:spcAft>
-                <a:spcPts val="1000"/>
+                <a:spcPts val="800"/>
               </a:spcAft>
             </a:pPr>
             <a:r>
@@ -4992,7 +6741,129 @@
                 </a:solidFill>
                 <a:latin typeface="Segoe UI"/>
               </a:rPr>
-              <a:t>AI absorbs the overhead — never the thinking.</a:t>
+              <a:t>AI absorbs the overhead — never the thinking. 🎯</a:t>
+            </a:r>
+          </a:p>
+        </p:txBody>
+      </p:sp>
+      <p:sp>
+        <p:nvSpPr>
+          <p:cNvPr id="11" name="Rectangle 10"/>
+          <p:cNvSpPr/>
+          <p:nvPr/>
+        </p:nvSpPr>
+        <p:spPr>
+          <a:xfrm>
+            <a:off x="502920" y="6473952"/>
+            <a:ext cx="457200" cy="41148"/>
+          </a:xfrm>
+          <a:prstGeom prst="rect">
+            <a:avLst/>
+          </a:prstGeom>
+          <a:solidFill>
+            <a:srgbClr val="2E8C8C"/>
+          </a:solidFill>
+          <a:ln>
+            <a:noFill/>
+          </a:ln>
+          <a:effectLst/>
+        </p:spPr>
+        <p:style>
+          <a:lnRef idx="1">
+            <a:schemeClr val="accent1"/>
+          </a:lnRef>
+          <a:fillRef idx="3">
+            <a:schemeClr val="accent1"/>
+          </a:fillRef>
+          <a:effectRef idx="2">
+            <a:schemeClr val="accent1"/>
+          </a:effectRef>
+          <a:fontRef idx="minor">
+            <a:schemeClr val="lt1"/>
+          </a:fontRef>
+        </p:style>
+        <p:txBody>
+          <a:bodyPr rtlCol="0" anchor="ctr"/>
+          <a:lstStyle/>
+          <a:p>
+            <a:pPr algn="ctr"/>
+          </a:p>
+        </p:txBody>
+      </p:sp>
+      <p:sp>
+        <p:nvSpPr>
+          <p:cNvPr id="12" name="TextBox 11"/>
+          <p:cNvSpPr txBox="1"/>
+          <p:nvPr/>
+        </p:nvSpPr>
+        <p:spPr>
+          <a:xfrm>
+            <a:off x="502920" y="6108192"/>
+            <a:ext cx="2743200" cy="365760"/>
+          </a:xfrm>
+          <a:prstGeom prst="rect">
+            <a:avLst/>
+          </a:prstGeom>
+          <a:noFill/>
+        </p:spPr>
+        <p:txBody>
+          <a:bodyPr wrap="square">
+            <a:spAutoFit/>
+          </a:bodyPr>
+          <a:lstStyle/>
+          <a:p>
+            <a:pPr algn="l">
+              <a:spcAft>
+                <a:spcPts val="800"/>
+              </a:spcAft>
+            </a:pPr>
+            <a:r>
+              <a:rPr sz="1200" b="1">
+                <a:solidFill>
+                  <a:srgbClr val="2E8C8C"/>
+                </a:solidFill>
+                <a:latin typeface="Segoe UI"/>
+              </a:rPr>
+              <a:t>enjoy ⚓</a:t>
+            </a:r>
+          </a:p>
+        </p:txBody>
+      </p:sp>
+      <p:sp>
+        <p:nvSpPr>
+          <p:cNvPr id="13" name="TextBox 12"/>
+          <p:cNvSpPr txBox="1"/>
+          <p:nvPr/>
+        </p:nvSpPr>
+        <p:spPr>
+          <a:xfrm>
+            <a:off x="11155680" y="6108192"/>
+            <a:ext cx="548640" cy="365760"/>
+          </a:xfrm>
+          <a:prstGeom prst="rect">
+            <a:avLst/>
+          </a:prstGeom>
+          <a:noFill/>
+        </p:spPr>
+        <p:txBody>
+          <a:bodyPr wrap="square">
+            <a:spAutoFit/>
+          </a:bodyPr>
+          <a:lstStyle/>
+          <a:p>
+            <a:pPr algn="r">
+              <a:spcAft>
+                <a:spcPts val="800"/>
+              </a:spcAft>
+            </a:pPr>
+            <a:r>
+              <a:rPr sz="1200" b="1">
+                <a:solidFill>
+                  <a:srgbClr val="2E8C8C"/>
+                </a:solidFill>
+                <a:latin typeface="Segoe UI"/>
+              </a:rPr>
+              <a:t>07</a:t>
             </a:r>
           </a:p>
         </p:txBody>
@@ -5025,14 +6896,92 @@
       <p:grpSpPr/>
       <p:sp>
         <p:nvSpPr>
-          <p:cNvPr id="2" name="Rectangle 1"/>
+          <p:cNvPr id="2" name="TextBox 1"/>
+          <p:cNvSpPr txBox="1"/>
+          <p:nvPr/>
+        </p:nvSpPr>
+        <p:spPr>
+          <a:xfrm>
+            <a:off x="914400" y="1188720"/>
+            <a:ext cx="10332720" cy="914400"/>
+          </a:xfrm>
+          <a:prstGeom prst="rect">
+            <a:avLst/>
+          </a:prstGeom>
+          <a:noFill/>
+        </p:spPr>
+        <p:txBody>
+          <a:bodyPr wrap="square">
+            <a:spAutoFit/>
+          </a:bodyPr>
+          <a:lstStyle/>
+          <a:p>
+            <a:pPr algn="ctr">
+              <a:spcAft>
+                <a:spcPts val="800"/>
+              </a:spcAft>
+            </a:pPr>
+            <a:r>
+              <a:rPr sz="5400" b="0">
+                <a:solidFill>
+                  <a:srgbClr val="F7F7F0"/>
+                </a:solidFill>
+                <a:latin typeface="Segoe UI Emoji"/>
+              </a:rPr>
+              <a:t>🏮</a:t>
+            </a:r>
+          </a:p>
+        </p:txBody>
+      </p:sp>
+      <p:sp>
+        <p:nvSpPr>
+          <p:cNvPr id="3" name="TextBox 2"/>
+          <p:cNvSpPr txBox="1"/>
+          <p:nvPr/>
+        </p:nvSpPr>
+        <p:spPr>
+          <a:xfrm>
+            <a:off x="914400" y="2194560"/>
+            <a:ext cx="10332720" cy="1097280"/>
+          </a:xfrm>
+          <a:prstGeom prst="rect">
+            <a:avLst/>
+          </a:prstGeom>
+          <a:noFill/>
+        </p:spPr>
+        <p:txBody>
+          <a:bodyPr wrap="square">
+            <a:spAutoFit/>
+          </a:bodyPr>
+          <a:lstStyle/>
+          <a:p>
+            <a:pPr algn="ctr">
+              <a:spcAft>
+                <a:spcPts val="800"/>
+              </a:spcAft>
+            </a:pPr>
+            <a:r>
+              <a:rPr sz="4600" b="1">
+                <a:solidFill>
+                  <a:srgbClr val="F7F7F0"/>
+                </a:solidFill>
+                <a:latin typeface="Segoe UI"/>
+              </a:rPr>
+              <a:t>The lamp records victories only.</a:t>
+            </a:r>
+          </a:p>
+        </p:txBody>
+      </p:sp>
+      <p:sp>
+        <p:nvSpPr>
+          <p:cNvPr id="4" name="Rectangle 3"/>
           <p:cNvSpPr/>
           <p:nvPr/>
         </p:nvSpPr>
         <p:spPr>
           <a:xfrm>
-            <a:off x="0" y="3291840"/>
-            <a:ext cx="12191695" cy="54864"/>
+            <a:off x="4480560" y="3520440"/>
+            <a:ext cx="3227832" cy="54864"/>
           </a:xfrm>
           <a:prstGeom prst="rect">
             <a:avLst/>
@@ -5069,14 +7018,14 @@
       </p:sp>
       <p:sp>
         <p:nvSpPr>
-          <p:cNvPr id="3" name="TextBox 2"/>
+          <p:cNvPr id="5" name="TextBox 4"/>
           <p:cNvSpPr txBox="1"/>
           <p:nvPr/>
         </p:nvSpPr>
         <p:spPr>
           <a:xfrm>
-            <a:off x="914400" y="2103120"/>
-            <a:ext cx="10362895" cy="2194560"/>
+            <a:off x="914400" y="3794760"/>
+            <a:ext cx="10332720" cy="731520"/>
           </a:xfrm>
           <a:prstGeom prst="rect">
             <a:avLst/>
@@ -5091,23 +7040,7 @@
           <a:p>
             <a:pPr algn="ctr">
               <a:spcAft>
-                <a:spcPts val="1000"/>
-              </a:spcAft>
-            </a:pPr>
-            <a:r>
-              <a:rPr sz="4800" b="1">
-                <a:solidFill>
-                  <a:srgbClr val="F7F7F0"/>
-                </a:solidFill>
-                <a:latin typeface="Segoe UI"/>
-              </a:rPr>
-              <a:t>The lamp records victories only.</a:t>
-            </a:r>
-          </a:p>
-          <a:p>
-            <a:pPr algn="ctr">
-              <a:spcAft>
-                <a:spcPts val="1000"/>
+                <a:spcPts val="800"/>
               </a:spcAft>
             </a:pPr>
             <a:r>
@@ -5117,7 +7050,168 @@
                 </a:solidFill>
                 <a:latin typeface="Segoe UI"/>
               </a:rPr>
-              <a:t>enjoy — come back to a harbour, never a bill.</a:t>
+              <a:t>enjoy — come back to a harbour, never a bill. ⚓</a:t>
+            </a:r>
+          </a:p>
+        </p:txBody>
+      </p:sp>
+      <p:sp>
+        <p:nvSpPr>
+          <p:cNvPr id="6" name="TextBox 5"/>
+          <p:cNvSpPr txBox="1"/>
+          <p:nvPr/>
+        </p:nvSpPr>
+        <p:spPr>
+          <a:xfrm>
+            <a:off x="914400" y="5029200"/>
+            <a:ext cx="10332720" cy="731520"/>
+          </a:xfrm>
+          <a:prstGeom prst="rect">
+            <a:avLst/>
+          </a:prstGeom>
+          <a:noFill/>
+        </p:spPr>
+        <p:txBody>
+          <a:bodyPr wrap="square">
+            <a:spAutoFit/>
+          </a:bodyPr>
+          <a:lstStyle/>
+          <a:p>
+            <a:pPr algn="ctr">
+              <a:spcAft>
+                <a:spcPts val="800"/>
+              </a:spcAft>
+            </a:pPr>
+            <a:r>
+              <a:rPr sz="2200" b="0">
+                <a:solidFill>
+                  <a:srgbClr val="EDEDDD"/>
+                </a:solidFill>
+                <a:latin typeface="Segoe UI"/>
+              </a:rPr>
+              <a:t>thank you 🙏</a:t>
+            </a:r>
+          </a:p>
+        </p:txBody>
+      </p:sp>
+      <p:sp>
+        <p:nvSpPr>
+          <p:cNvPr id="7" name="Rectangle 6"/>
+          <p:cNvSpPr/>
+          <p:nvPr/>
+        </p:nvSpPr>
+        <p:spPr>
+          <a:xfrm>
+            <a:off x="502920" y="6473952"/>
+            <a:ext cx="457200" cy="41148"/>
+          </a:xfrm>
+          <a:prstGeom prst="rect">
+            <a:avLst/>
+          </a:prstGeom>
+          <a:solidFill>
+            <a:srgbClr val="D8E4E0"/>
+          </a:solidFill>
+          <a:ln>
+            <a:noFill/>
+          </a:ln>
+          <a:effectLst/>
+        </p:spPr>
+        <p:style>
+          <a:lnRef idx="1">
+            <a:schemeClr val="accent1"/>
+          </a:lnRef>
+          <a:fillRef idx="3">
+            <a:schemeClr val="accent1"/>
+          </a:fillRef>
+          <a:effectRef idx="2">
+            <a:schemeClr val="accent1"/>
+          </a:effectRef>
+          <a:fontRef idx="minor">
+            <a:schemeClr val="lt1"/>
+          </a:fontRef>
+        </p:style>
+        <p:txBody>
+          <a:bodyPr rtlCol="0" anchor="ctr"/>
+          <a:lstStyle/>
+          <a:p>
+            <a:pPr algn="ctr"/>
+          </a:p>
+        </p:txBody>
+      </p:sp>
+      <p:sp>
+        <p:nvSpPr>
+          <p:cNvPr id="8" name="TextBox 7"/>
+          <p:cNvSpPr txBox="1"/>
+          <p:nvPr/>
+        </p:nvSpPr>
+        <p:spPr>
+          <a:xfrm>
+            <a:off x="502920" y="6108192"/>
+            <a:ext cx="2743200" cy="365760"/>
+          </a:xfrm>
+          <a:prstGeom prst="rect">
+            <a:avLst/>
+          </a:prstGeom>
+          <a:noFill/>
+        </p:spPr>
+        <p:txBody>
+          <a:bodyPr wrap="square">
+            <a:spAutoFit/>
+          </a:bodyPr>
+          <a:lstStyle/>
+          <a:p>
+            <a:pPr algn="l">
+              <a:spcAft>
+                <a:spcPts val="800"/>
+              </a:spcAft>
+            </a:pPr>
+            <a:r>
+              <a:rPr sz="1200" b="1">
+                <a:solidFill>
+                  <a:srgbClr val="D8E4E0"/>
+                </a:solidFill>
+                <a:latin typeface="Segoe UI"/>
+              </a:rPr>
+              <a:t>enjoy ⚓</a:t>
+            </a:r>
+          </a:p>
+        </p:txBody>
+      </p:sp>
+      <p:sp>
+        <p:nvSpPr>
+          <p:cNvPr id="9" name="TextBox 8"/>
+          <p:cNvSpPr txBox="1"/>
+          <p:nvPr/>
+        </p:nvSpPr>
+        <p:spPr>
+          <a:xfrm>
+            <a:off x="11155680" y="6108192"/>
+            <a:ext cx="548640" cy="365760"/>
+          </a:xfrm>
+          <a:prstGeom prst="rect">
+            <a:avLst/>
+          </a:prstGeom>
+          <a:noFill/>
+        </p:spPr>
+        <p:txBody>
+          <a:bodyPr wrap="square">
+            <a:spAutoFit/>
+          </a:bodyPr>
+          <a:lstStyle/>
+          <a:p>
+            <a:pPr algn="r">
+              <a:spcAft>
+                <a:spcPts val="800"/>
+              </a:spcAft>
+            </a:pPr>
+            <a:r>
+              <a:rPr sz="1200" b="1">
+                <a:solidFill>
+                  <a:srgbClr val="D8E4E0"/>
+                </a:solidFill>
+                <a:latin typeface="Segoe UI"/>
+              </a:rPr>
+              <a:t>08</a:t>
             </a:r>
           </a:p>
         </p:txBody>

</xml_diff>

<commit_message>
submission: P1 finale + polish pass (sessions 023-033) + README refresh
- Backend: P1 ingestion/flashcards/KG pipeline (apkg export, FSRS, golden
  path E2E); suite verified 202 passed, 96.46% coverage
- Frontend: calm chrome UI, peel-out review selection + halo + chase POV,
  flotilla freeze mid-review, R=180 ring, camera landing fixes
- Docs: pitch deck v2 + 2-min script, handoffs, session logs 023-033
- README: current-state update, presentation docs row
- .gitattributes: binary assets protected from CRLF; gitignore: ~$ Office
  locks
</commit_message>
<xml_diff>
--- a/docs/presentation/enjoy-pitch.pptx
+++ b/docs/presentation/enjoy-pitch.pptx
@@ -13,6 +13,7 @@
     <p:sldId id="261" r:id="rId13"/>
     <p:sldId id="262" r:id="rId14"/>
     <p:sldId id="263" r:id="rId15"/>
+    <p:sldId id="264" r:id="rId16"/>
   </p:sldIdLst>
   <p:sldSz cx="12191695" cy="6858000" type="screen4x3"/>
   <p:notesSz cx="6858000" cy="9144000"/>
@@ -929,7 +930,7 @@
           <a:lstStyle/>
           <a:p>
             <a:r>
-              <a:t>1:45-1:55 — don't read bullets; 'agents do the plumbing, Postgres is the single truth, AI never studies FOR you.'</a:t>
+              <a:t>1:45-1:55 — talk ONLY the top 3: multi-agent for quality, LangChain to guide the AI, Three.js for the world. Point at the full list, don't read it.</a:t>
             </a:r>
           </a:p>
         </p:txBody>
@@ -955,6 +956,76 @@
 </file>
 
 <file path=ppt/notesSlides/notesSlide8.xml><?xml version="1.0" encoding="utf-8"?>
+<p:notes xmlns:a="http://schemas.openxmlformats.org/drawingml/2006/main" xmlns:p="http://schemas.openxmlformats.org/presentationml/2006/main" xmlns:r="http://schemas.openxmlformats.org/officeDocument/2006/relationships">
+  <p:cSld>
+    <p:spTree>
+      <p:nvGrpSpPr>
+        <p:cNvPr id="1" name=""/>
+        <p:cNvGrpSpPr/>
+        <p:nvPr/>
+      </p:nvGrpSpPr>
+      <p:grpSpPr>
+        <a:xfrm>
+          <a:off x="0" y="0"/>
+          <a:ext cx="0" cy="0"/>
+          <a:chOff x="0" y="0"/>
+          <a:chExt cx="0" cy="0"/>
+        </a:xfrm>
+      </p:grpSpPr>
+      <p:sp>
+        <p:nvSpPr>
+          <p:cNvPr id="2" name="Slide Image Placeholder 1"/>
+          <p:cNvSpPr>
+            <a:spLocks noGrp="1"/>
+          </p:cNvSpPr>
+          <p:nvPr>
+            <p:ph type="sldImg" idx="2"/>
+          </p:nvPr>
+        </p:nvSpPr>
+        <p:spPr/>
+      </p:sp>
+      <p:sp>
+        <p:nvSpPr>
+          <p:cNvPr id="3" name="Notes Placeholder 2"/>
+          <p:cNvSpPr>
+            <a:spLocks noGrp="1"/>
+          </p:cNvSpPr>
+          <p:nvPr>
+            <p:ph type="body" idx="3" sz="quarter"/>
+          </p:nvPr>
+        </p:nvSpPr>
+        <p:spPr/>
+        <p:txBody>
+          <a:bodyPr/>
+          <a:lstStyle/>
+          <a:p>
+            <a:r>
+              <a:t>Credit slide — not spoken in the 2:00. If asked about tech: 'each agent stands on proven open source — the list is in our repo.'</a:t>
+            </a:r>
+          </a:p>
+        </p:txBody>
+      </p:sp>
+      <p:sp>
+        <p:nvSpPr>
+          <p:cNvPr id="4" name="Slide Number Placeholder 3"/>
+          <p:cNvSpPr>
+            <a:spLocks noGrp="1"/>
+          </p:cNvSpPr>
+          <p:nvPr>
+            <p:ph type="sldNum" idx="5" sz="quarter"/>
+          </p:nvPr>
+        </p:nvSpPr>
+        <p:spPr/>
+      </p:sp>
+    </p:spTree>
+  </p:cSld>
+  <p:clrMapOvr>
+    <a:masterClrMapping/>
+  </p:clrMapOvr>
+</p:notes>
+</file>
+
+<file path=ppt/notesSlides/notesSlide9.xml><?xml version="1.0" encoding="utf-8"?>
 <p:notes xmlns:a="http://schemas.openxmlformats.org/drawingml/2006/main" xmlns:p="http://schemas.openxmlformats.org/presentationml/2006/main" xmlns:r="http://schemas.openxmlformats.org/officeDocument/2006/relationships">
   <p:cSld>
     <p:spTree>
@@ -6414,7 +6485,7 @@
                 </a:solidFill>
                 <a:latin typeface="Segoe UI"/>
               </a:rPr>
-              <a:t>UNDER THE HOOD ⚙️</a:t>
+              <a:t>TECH STACK ⚙️</a:t>
             </a:r>
           </a:p>
         </p:txBody>
@@ -6427,7 +6498,7 @@
         </p:nvSpPr>
         <p:spPr>
           <a:xfrm>
-            <a:off x="777240" y="914400"/>
+            <a:off x="777240" y="868680"/>
             <a:ext cx="10607040" cy="1188720"/>
           </a:xfrm>
           <a:prstGeom prst="rect">
@@ -6447,13 +6518,13 @@
               </a:spcAft>
             </a:pPr>
             <a:r>
-              <a:rPr sz="4400" b="1">
+              <a:rPr sz="3800" b="1">
                 <a:solidFill>
                   <a:srgbClr val="1A203B"/>
                 </a:solidFill>
                 <a:latin typeface="Segoe UI"/>
               </a:rPr>
-              <a:t>Built to be trusted 🔧</a:t>
+              <a:t>Why this stack 🧰</a:t>
             </a:r>
           </a:p>
         </p:txBody>
@@ -6466,8 +6537,8 @@
         </p:nvSpPr>
         <p:spPr>
           <a:xfrm>
-            <a:off x="1005840" y="2286000"/>
-            <a:ext cx="10149840" cy="822960"/>
+            <a:off x="1005840" y="1874519"/>
+            <a:ext cx="3264408" cy="1371600"/>
           </a:xfrm>
           <a:prstGeom prst="roundRect">
             <a:avLst/>
@@ -6510,8 +6581,8 @@
         </p:nvSpPr>
         <p:spPr>
           <a:xfrm>
-            <a:off x="1325880" y="2395728"/>
-            <a:ext cx="9509760" cy="603504"/>
+            <a:off x="1325880" y="1984248"/>
+            <a:ext cx="2624328" cy="1152144"/>
           </a:xfrm>
           <a:prstGeom prst="rect">
             <a:avLst/>
@@ -6530,13 +6601,29 @@
               </a:spcAft>
             </a:pPr>
             <a:r>
-              <a:rPr sz="2200" b="0">
+              <a:rPr sz="2200" b="1">
                 <a:solidFill>
                   <a:srgbClr val="1A203B"/>
                 </a:solidFill>
                 <a:latin typeface="Segoe UI"/>
               </a:rPr>
-              <a:t>🧠  FastAPI + agent orchestrator  →  planner · flashcards · graph</a:t>
+              <a:t>🤖  Multi-agent system</a:t>
+            </a:r>
+          </a:p>
+          <a:p>
+            <a:pPr algn="l">
+              <a:spcAft>
+                <a:spcPts val="800"/>
+              </a:spcAft>
+            </a:pPr>
+            <a:r>
+              <a:rPr sz="1600" b="0">
+                <a:solidFill>
+                  <a:srgbClr val="0F4C5C"/>
+                </a:solidFill>
+                <a:latin typeface="Segoe UI"/>
+              </a:rPr>
+              <a:t>specialised agents  →  higher quality</a:t>
             </a:r>
           </a:p>
         </p:txBody>
@@ -6549,8 +6636,8 @@
         </p:nvSpPr>
         <p:spPr>
           <a:xfrm>
-            <a:off x="1005840" y="3310128"/>
-            <a:ext cx="10149840" cy="822960"/>
+            <a:off x="4453128" y="1874519"/>
+            <a:ext cx="3264408" cy="1371600"/>
           </a:xfrm>
           <a:prstGeom prst="roundRect">
             <a:avLst/>
@@ -6593,8 +6680,8 @@
         </p:nvSpPr>
         <p:spPr>
           <a:xfrm>
-            <a:off x="1325880" y="3419856"/>
-            <a:ext cx="9509760" cy="603504"/>
+            <a:off x="4773168" y="1984248"/>
+            <a:ext cx="2624328" cy="1152144"/>
           </a:xfrm>
           <a:prstGeom prst="rect">
             <a:avLst/>
@@ -6613,13 +6700,29 @@
               </a:spcAft>
             </a:pPr>
             <a:r>
-              <a:rPr sz="2200" b="0">
+              <a:rPr sz="2200" b="1">
                 <a:solidFill>
                   <a:srgbClr val="1A203B"/>
                 </a:solidFill>
                 <a:latin typeface="Segoe UI"/>
               </a:rPr>
-              <a:t>🗄️  Postgres + one ordered event stream  →  world never drifts</a:t>
+              <a:t>🦜🔗  LangChain</a:t>
+            </a:r>
+          </a:p>
+          <a:p>
+            <a:pPr algn="l">
+              <a:spcAft>
+                <a:spcPts val="800"/>
+              </a:spcAft>
+            </a:pPr>
+            <a:r>
+              <a:rPr sz="1600" b="0">
+                <a:solidFill>
+                  <a:srgbClr val="0F4C5C"/>
+                </a:solidFill>
+                <a:latin typeface="Segoe UI"/>
+              </a:rPr>
+              <a:t>guides the AI  →  controlled, reliable output</a:t>
             </a:r>
           </a:p>
         </p:txBody>
@@ -6632,8 +6735,8 @@
         </p:nvSpPr>
         <p:spPr>
           <a:xfrm>
-            <a:off x="1005840" y="4334256"/>
-            <a:ext cx="10149840" cy="822960"/>
+            <a:off x="7900416" y="1874519"/>
+            <a:ext cx="3264408" cy="1371600"/>
           </a:xfrm>
           <a:prstGeom prst="roundRect">
             <a:avLst/>
@@ -6676,8 +6779,8 @@
         </p:nvSpPr>
         <p:spPr>
           <a:xfrm>
-            <a:off x="1325880" y="4443984"/>
-            <a:ext cx="9509760" cy="603504"/>
+            <a:off x="8220456" y="1984248"/>
+            <a:ext cx="2624328" cy="1152144"/>
           </a:xfrm>
           <a:prstGeom prst="rect">
             <a:avLst/>
@@ -6696,59 +6799,581 @@
               </a:spcAft>
             </a:pPr>
             <a:r>
-              <a:rPr sz="2200" b="0">
+              <a:rPr sz="2200" b="1">
                 <a:solidFill>
                   <a:srgbClr val="1A203B"/>
                 </a:solidFill>
                 <a:latin typeface="Segoe UI"/>
               </a:rPr>
-              <a:t>🕸️  Next.js + three.js  →  one runtime path, no mock modes</a:t>
-            </a:r>
-          </a:p>
-        </p:txBody>
-      </p:sp>
-      <p:sp>
-        <p:nvSpPr>
-          <p:cNvPr id="10" name="TextBox 9"/>
-          <p:cNvSpPr txBox="1"/>
-          <p:nvPr/>
-        </p:nvSpPr>
-        <p:spPr>
-          <a:xfrm>
-            <a:off x="914400" y="5486400"/>
-            <a:ext cx="10332720" cy="640080"/>
-          </a:xfrm>
-          <a:prstGeom prst="rect">
-            <a:avLst/>
-          </a:prstGeom>
-          <a:noFill/>
-        </p:spPr>
-        <p:txBody>
-          <a:bodyPr wrap="square">
-            <a:spAutoFit/>
-          </a:bodyPr>
-          <a:lstStyle/>
-          <a:p>
-            <a:pPr algn="ctr">
+              <a:t>🕸️  Three.js</a:t>
+            </a:r>
+          </a:p>
+          <a:p>
+            <a:pPr algn="l">
               <a:spcAft>
                 <a:spcPts val="800"/>
               </a:spcAft>
             </a:pPr>
             <a:r>
-              <a:rPr sz="2600" b="1">
+              <a:rPr sz="1600" b="0">
                 <a:solidFill>
                   <a:srgbClr val="0F4C5C"/>
                 </a:solidFill>
                 <a:latin typeface="Segoe UI"/>
               </a:rPr>
-              <a:t>AI absorbs the overhead — never the thinking. 🎯</a:t>
-            </a:r>
-          </a:p>
-        </p:txBody>
-      </p:sp>
-      <p:sp>
-        <p:nvSpPr>
-          <p:cNvPr id="11" name="Rectangle 10"/>
+              <a:t>powers the 3D game world in the browser</a:t>
+            </a:r>
+          </a:p>
+        </p:txBody>
+      </p:sp>
+      <p:sp>
+        <p:nvSpPr>
+          <p:cNvPr id="10" name="Rectangle 9"/>
+          <p:cNvSpPr/>
+          <p:nvPr/>
+        </p:nvSpPr>
+        <p:spPr>
+          <a:xfrm>
+            <a:off x="1005840" y="3520440"/>
+            <a:ext cx="10149840" cy="457200"/>
+          </a:xfrm>
+          <a:prstGeom prst="rect">
+            <a:avLst/>
+          </a:prstGeom>
+          <a:solidFill>
+            <a:srgbClr val="0F4C5C"/>
+          </a:solidFill>
+          <a:ln>
+            <a:noFill/>
+          </a:ln>
+          <a:effectLst/>
+        </p:spPr>
+        <p:style>
+          <a:lnRef idx="1">
+            <a:schemeClr val="accent1"/>
+          </a:lnRef>
+          <a:fillRef idx="3">
+            <a:schemeClr val="accent1"/>
+          </a:fillRef>
+          <a:effectRef idx="2">
+            <a:schemeClr val="accent1"/>
+          </a:effectRef>
+          <a:fontRef idx="minor">
+            <a:schemeClr val="lt1"/>
+          </a:fontRef>
+        </p:style>
+        <p:txBody>
+          <a:bodyPr rtlCol="0" anchor="ctr"/>
+          <a:lstStyle/>
+          <a:p>
+            <a:pPr algn="ctr"/>
+          </a:p>
+        </p:txBody>
+      </p:sp>
+      <p:sp>
+        <p:nvSpPr>
+          <p:cNvPr id="11" name="TextBox 10"/>
+          <p:cNvSpPr txBox="1"/>
+          <p:nvPr/>
+        </p:nvSpPr>
+        <p:spPr>
+          <a:xfrm>
+            <a:off x="1325880" y="3584448"/>
+            <a:ext cx="9509760" cy="365760"/>
+          </a:xfrm>
+          <a:prstGeom prst="rect">
+            <a:avLst/>
+          </a:prstGeom>
+          <a:noFill/>
+        </p:spPr>
+        <p:txBody>
+          <a:bodyPr wrap="square">
+            <a:spAutoFit/>
+          </a:bodyPr>
+          <a:lstStyle/>
+          <a:p>
+            <a:pPr algn="l">
+              <a:spcAft>
+                <a:spcPts val="800"/>
+              </a:spcAft>
+            </a:pPr>
+            <a:r>
+              <a:rPr sz="1600" b="1">
+                <a:solidFill>
+                  <a:srgbClr val="F7F7F0"/>
+                </a:solidFill>
+                <a:latin typeface="Segoe UI"/>
+              </a:rPr>
+              <a:t>THE FULL STACK</a:t>
+            </a:r>
+          </a:p>
+        </p:txBody>
+      </p:sp>
+      <p:sp>
+        <p:nvSpPr>
+          <p:cNvPr id="12" name="Rectangle 11"/>
+          <p:cNvSpPr/>
+          <p:nvPr/>
+        </p:nvSpPr>
+        <p:spPr>
+          <a:xfrm>
+            <a:off x="1005840" y="3977639"/>
+            <a:ext cx="3264408" cy="1965960"/>
+          </a:xfrm>
+          <a:prstGeom prst="rect">
+            <a:avLst/>
+          </a:prstGeom>
+          <a:solidFill>
+            <a:srgbClr val="D8E4E0"/>
+          </a:solidFill>
+          <a:ln>
+            <a:noFill/>
+          </a:ln>
+          <a:effectLst/>
+        </p:spPr>
+        <p:style>
+          <a:lnRef idx="1">
+            <a:schemeClr val="accent1"/>
+          </a:lnRef>
+          <a:fillRef idx="3">
+            <a:schemeClr val="accent1"/>
+          </a:fillRef>
+          <a:effectRef idx="2">
+            <a:schemeClr val="accent1"/>
+          </a:effectRef>
+          <a:fontRef idx="minor">
+            <a:schemeClr val="lt1"/>
+          </a:fontRef>
+        </p:style>
+        <p:txBody>
+          <a:bodyPr rtlCol="0" anchor="ctr"/>
+          <a:lstStyle/>
+          <a:p>
+            <a:pPr algn="ctr"/>
+          </a:p>
+        </p:txBody>
+      </p:sp>
+      <p:sp>
+        <p:nvSpPr>
+          <p:cNvPr id="13" name="TextBox 12"/>
+          <p:cNvSpPr txBox="1"/>
+          <p:nvPr/>
+        </p:nvSpPr>
+        <p:spPr>
+          <a:xfrm>
+            <a:off x="1280160" y="4114800"/>
+            <a:ext cx="2743200" cy="365760"/>
+          </a:xfrm>
+          <a:prstGeom prst="rect">
+            <a:avLst/>
+          </a:prstGeom>
+          <a:noFill/>
+        </p:spPr>
+        <p:txBody>
+          <a:bodyPr wrap="square">
+            <a:spAutoFit/>
+          </a:bodyPr>
+          <a:lstStyle/>
+          <a:p>
+            <a:pPr algn="l">
+              <a:spcAft>
+                <a:spcPts val="800"/>
+              </a:spcAft>
+            </a:pPr>
+            <a:r>
+              <a:rPr sz="1500" b="1">
+                <a:solidFill>
+                  <a:srgbClr val="0F4C5C"/>
+                </a:solidFill>
+                <a:latin typeface="Segoe UI"/>
+              </a:rPr>
+              <a:t>FRONTEND 🖥️</a:t>
+            </a:r>
+          </a:p>
+        </p:txBody>
+      </p:sp>
+      <p:sp>
+        <p:nvSpPr>
+          <p:cNvPr id="14" name="TextBox 13"/>
+          <p:cNvSpPr txBox="1"/>
+          <p:nvPr/>
+        </p:nvSpPr>
+        <p:spPr>
+          <a:xfrm>
+            <a:off x="1280160" y="4526280"/>
+            <a:ext cx="2788920" cy="1371600"/>
+          </a:xfrm>
+          <a:prstGeom prst="rect">
+            <a:avLst/>
+          </a:prstGeom>
+          <a:noFill/>
+        </p:spPr>
+        <p:txBody>
+          <a:bodyPr wrap="square">
+            <a:spAutoFit/>
+          </a:bodyPr>
+          <a:lstStyle/>
+          <a:p>
+            <a:pPr algn="l">
+              <a:spcAft>
+                <a:spcPts val="800"/>
+              </a:spcAft>
+            </a:pPr>
+            <a:r>
+              <a:rPr sz="1350" b="0">
+                <a:solidFill>
+                  <a:srgbClr val="1A203B"/>
+                </a:solidFill>
+                <a:latin typeface="Segoe UI"/>
+              </a:rPr>
+              <a:t>Next.js 16  ·  React 19  ·  TypeScript</a:t>
+            </a:r>
+          </a:p>
+          <a:p>
+            <a:pPr algn="l">
+              <a:spcAft>
+                <a:spcPts val="800"/>
+              </a:spcAft>
+            </a:pPr>
+            <a:r>
+              <a:rPr sz="1350" b="0">
+                <a:solidFill>
+                  <a:srgbClr val="1A203B"/>
+                </a:solidFill>
+                <a:latin typeface="Segoe UI"/>
+              </a:rPr>
+              <a:t>Three.js  +  react-three-fiber</a:t>
+            </a:r>
+          </a:p>
+          <a:p>
+            <a:pPr algn="l">
+              <a:spcAft>
+                <a:spcPts val="800"/>
+              </a:spcAft>
+            </a:pPr>
+            <a:r>
+              <a:rPr sz="1350" b="0">
+                <a:solidFill>
+                  <a:srgbClr val="1A203B"/>
+                </a:solidFill>
+                <a:latin typeface="Segoe UI"/>
+              </a:rPr>
+              <a:t>Zustand  ·  Tailwind CSS</a:t>
+            </a:r>
+          </a:p>
+        </p:txBody>
+      </p:sp>
+      <p:sp>
+        <p:nvSpPr>
+          <p:cNvPr id="15" name="Rectangle 14"/>
+          <p:cNvSpPr/>
+          <p:nvPr/>
+        </p:nvSpPr>
+        <p:spPr>
+          <a:xfrm>
+            <a:off x="4453128" y="3977639"/>
+            <a:ext cx="3264408" cy="1965960"/>
+          </a:xfrm>
+          <a:prstGeom prst="rect">
+            <a:avLst/>
+          </a:prstGeom>
+          <a:solidFill>
+            <a:srgbClr val="D8E4E0"/>
+          </a:solidFill>
+          <a:ln>
+            <a:noFill/>
+          </a:ln>
+          <a:effectLst/>
+        </p:spPr>
+        <p:style>
+          <a:lnRef idx="1">
+            <a:schemeClr val="accent1"/>
+          </a:lnRef>
+          <a:fillRef idx="3">
+            <a:schemeClr val="accent1"/>
+          </a:fillRef>
+          <a:effectRef idx="2">
+            <a:schemeClr val="accent1"/>
+          </a:effectRef>
+          <a:fontRef idx="minor">
+            <a:schemeClr val="lt1"/>
+          </a:fontRef>
+        </p:style>
+        <p:txBody>
+          <a:bodyPr rtlCol="0" anchor="ctr"/>
+          <a:lstStyle/>
+          <a:p>
+            <a:pPr algn="ctr"/>
+          </a:p>
+        </p:txBody>
+      </p:sp>
+      <p:sp>
+        <p:nvSpPr>
+          <p:cNvPr id="16" name="TextBox 15"/>
+          <p:cNvSpPr txBox="1"/>
+          <p:nvPr/>
+        </p:nvSpPr>
+        <p:spPr>
+          <a:xfrm>
+            <a:off x="4727448" y="4114800"/>
+            <a:ext cx="2743200" cy="365760"/>
+          </a:xfrm>
+          <a:prstGeom prst="rect">
+            <a:avLst/>
+          </a:prstGeom>
+          <a:noFill/>
+        </p:spPr>
+        <p:txBody>
+          <a:bodyPr wrap="square">
+            <a:spAutoFit/>
+          </a:bodyPr>
+          <a:lstStyle/>
+          <a:p>
+            <a:pPr algn="l">
+              <a:spcAft>
+                <a:spcPts val="800"/>
+              </a:spcAft>
+            </a:pPr>
+            <a:r>
+              <a:rPr sz="1500" b="1">
+                <a:solidFill>
+                  <a:srgbClr val="0F4C5C"/>
+                </a:solidFill>
+                <a:latin typeface="Segoe UI"/>
+              </a:rPr>
+              <a:t>BACKEND 🧠</a:t>
+            </a:r>
+          </a:p>
+        </p:txBody>
+      </p:sp>
+      <p:sp>
+        <p:nvSpPr>
+          <p:cNvPr id="17" name="TextBox 16"/>
+          <p:cNvSpPr txBox="1"/>
+          <p:nvPr/>
+        </p:nvSpPr>
+        <p:spPr>
+          <a:xfrm>
+            <a:off x="4727448" y="4526280"/>
+            <a:ext cx="2788920" cy="1371600"/>
+          </a:xfrm>
+          <a:prstGeom prst="rect">
+            <a:avLst/>
+          </a:prstGeom>
+          <a:noFill/>
+        </p:spPr>
+        <p:txBody>
+          <a:bodyPr wrap="square">
+            <a:spAutoFit/>
+          </a:bodyPr>
+          <a:lstStyle/>
+          <a:p>
+            <a:pPr algn="l">
+              <a:spcAft>
+                <a:spcPts val="800"/>
+              </a:spcAft>
+            </a:pPr>
+            <a:r>
+              <a:rPr sz="1350" b="0">
+                <a:solidFill>
+                  <a:srgbClr val="1A203B"/>
+                </a:solidFill>
+                <a:latin typeface="Segoe UI"/>
+              </a:rPr>
+              <a:t>Python 3.12  ·  FastAPI  ·  Pydantic</a:t>
+            </a:r>
+          </a:p>
+          <a:p>
+            <a:pPr algn="l">
+              <a:spcAft>
+                <a:spcPts val="800"/>
+              </a:spcAft>
+            </a:pPr>
+            <a:r>
+              <a:rPr sz="1350" b="0">
+                <a:solidFill>
+                  <a:srgbClr val="1A203B"/>
+                </a:solidFill>
+                <a:latin typeface="Segoe UI"/>
+              </a:rPr>
+              <a:t>Multi-agent: orchestrator · planner · flashcards</a:t>
+            </a:r>
+          </a:p>
+          <a:p>
+            <a:pPr algn="l">
+              <a:spcAft>
+                <a:spcPts val="800"/>
+              </a:spcAft>
+            </a:pPr>
+            <a:r>
+              <a:rPr sz="1350" b="0">
+                <a:solidFill>
+                  <a:srgbClr val="1A203B"/>
+                </a:solidFill>
+                <a:latin typeface="Segoe UI"/>
+              </a:rPr>
+              <a:t>LangChain / LangGraph  ·  SSE streaming</a:t>
+            </a:r>
+          </a:p>
+        </p:txBody>
+      </p:sp>
+      <p:sp>
+        <p:nvSpPr>
+          <p:cNvPr id="18" name="Rectangle 17"/>
+          <p:cNvSpPr/>
+          <p:nvPr/>
+        </p:nvSpPr>
+        <p:spPr>
+          <a:xfrm>
+            <a:off x="7900416" y="3977639"/>
+            <a:ext cx="3264408" cy="1965960"/>
+          </a:xfrm>
+          <a:prstGeom prst="rect">
+            <a:avLst/>
+          </a:prstGeom>
+          <a:solidFill>
+            <a:srgbClr val="D8E4E0"/>
+          </a:solidFill>
+          <a:ln>
+            <a:noFill/>
+          </a:ln>
+          <a:effectLst/>
+        </p:spPr>
+        <p:style>
+          <a:lnRef idx="1">
+            <a:schemeClr val="accent1"/>
+          </a:lnRef>
+          <a:fillRef idx="3">
+            <a:schemeClr val="accent1"/>
+          </a:fillRef>
+          <a:effectRef idx="2">
+            <a:schemeClr val="accent1"/>
+          </a:effectRef>
+          <a:fontRef idx="minor">
+            <a:schemeClr val="lt1"/>
+          </a:fontRef>
+        </p:style>
+        <p:txBody>
+          <a:bodyPr rtlCol="0" anchor="ctr"/>
+          <a:lstStyle/>
+          <a:p>
+            <a:pPr algn="ctr"/>
+          </a:p>
+        </p:txBody>
+      </p:sp>
+      <p:sp>
+        <p:nvSpPr>
+          <p:cNvPr id="19" name="TextBox 18"/>
+          <p:cNvSpPr txBox="1"/>
+          <p:nvPr/>
+        </p:nvSpPr>
+        <p:spPr>
+          <a:xfrm>
+            <a:off x="8174736" y="4114800"/>
+            <a:ext cx="2743200" cy="365760"/>
+          </a:xfrm>
+          <a:prstGeom prst="rect">
+            <a:avLst/>
+          </a:prstGeom>
+          <a:noFill/>
+        </p:spPr>
+        <p:txBody>
+          <a:bodyPr wrap="square">
+            <a:spAutoFit/>
+          </a:bodyPr>
+          <a:lstStyle/>
+          <a:p>
+            <a:pPr algn="l">
+              <a:spcAft>
+                <a:spcPts val="800"/>
+              </a:spcAft>
+            </a:pPr>
+            <a:r>
+              <a:rPr sz="1500" b="1">
+                <a:solidFill>
+                  <a:srgbClr val="0F4C5C"/>
+                </a:solidFill>
+                <a:latin typeface="Segoe UI"/>
+              </a:rPr>
+              <a:t>DATA &amp; INFRA 🗄️</a:t>
+            </a:r>
+          </a:p>
+        </p:txBody>
+      </p:sp>
+      <p:sp>
+        <p:nvSpPr>
+          <p:cNvPr id="20" name="TextBox 19"/>
+          <p:cNvSpPr txBox="1"/>
+          <p:nvPr/>
+        </p:nvSpPr>
+        <p:spPr>
+          <a:xfrm>
+            <a:off x="8174736" y="4526280"/>
+            <a:ext cx="2788920" cy="1371600"/>
+          </a:xfrm>
+          <a:prstGeom prst="rect">
+            <a:avLst/>
+          </a:prstGeom>
+          <a:noFill/>
+        </p:spPr>
+        <p:txBody>
+          <a:bodyPr wrap="square">
+            <a:spAutoFit/>
+          </a:bodyPr>
+          <a:lstStyle/>
+          <a:p>
+            <a:pPr algn="l">
+              <a:spcAft>
+                <a:spcPts val="800"/>
+              </a:spcAft>
+            </a:pPr>
+            <a:r>
+              <a:rPr sz="1350" b="0">
+                <a:solidFill>
+                  <a:srgbClr val="1A203B"/>
+                </a:solidFill>
+                <a:latin typeface="Segoe UI"/>
+              </a:rPr>
+              <a:t>PostgreSQL 16  ·  SQLAlchemy async</a:t>
+            </a:r>
+          </a:p>
+          <a:p>
+            <a:pPr algn="l">
+              <a:spcAft>
+                <a:spcPts val="800"/>
+              </a:spcAft>
+            </a:pPr>
+            <a:r>
+              <a:rPr sz="1350" b="0">
+                <a:solidFill>
+                  <a:srgbClr val="1A203B"/>
+                </a:solidFill>
+                <a:latin typeface="Segoe UI"/>
+              </a:rPr>
+              <a:t>Alembic migrations  ·  Docker Compose</a:t>
+            </a:r>
+          </a:p>
+          <a:p>
+            <a:pPr algn="l">
+              <a:spcAft>
+                <a:spcPts val="800"/>
+              </a:spcAft>
+            </a:pPr>
+            <a:r>
+              <a:rPr sz="1350" b="0">
+                <a:solidFill>
+                  <a:srgbClr val="1A203B"/>
+                </a:solidFill>
+                <a:latin typeface="Segoe UI"/>
+              </a:rPr>
+              <a:t>event-sourced world state  →  never drifts</a:t>
+            </a:r>
+          </a:p>
+        </p:txBody>
+      </p:sp>
+      <p:sp>
+        <p:nvSpPr>
+          <p:cNvPr id="21" name="Rectangle 20"/>
           <p:cNvSpPr/>
           <p:nvPr/>
         </p:nvSpPr>
@@ -6792,7 +7417,7 @@
       </p:sp>
       <p:sp>
         <p:nvSpPr>
-          <p:cNvPr id="12" name="TextBox 11"/>
+          <p:cNvPr id="22" name="TextBox 21"/>
           <p:cNvSpPr txBox="1"/>
           <p:nvPr/>
         </p:nvSpPr>
@@ -6831,7 +7456,7 @@
       </p:sp>
       <p:sp>
         <p:nvSpPr>
-          <p:cNvPr id="13" name="TextBox 12"/>
+          <p:cNvPr id="23" name="TextBox 22"/>
           <p:cNvSpPr txBox="1"/>
           <p:nvPr/>
         </p:nvSpPr>
@@ -6877,6 +7502,865 @@
 </file>
 
 <file path=ppt/slides/slide8.xml><?xml version="1.0" encoding="utf-8"?>
+<p:sld xmlns:a="http://schemas.openxmlformats.org/drawingml/2006/main" xmlns:p="http://schemas.openxmlformats.org/presentationml/2006/main" xmlns:r="http://schemas.openxmlformats.org/officeDocument/2006/relationships">
+  <p:cSld>
+    <p:bg>
+      <p:bgPr>
+        <a:solidFill>
+          <a:srgbClr val="0F4C5C"/>
+        </a:solidFill>
+        <a:effectLst/>
+      </p:bgPr>
+    </p:bg>
+    <p:spTree>
+      <p:nvGrpSpPr>
+        <p:cNvPr id="1" name=""/>
+        <p:cNvGrpSpPr/>
+        <p:nvPr/>
+      </p:nvGrpSpPr>
+      <p:grpSpPr/>
+      <p:sp>
+        <p:nvSpPr>
+          <p:cNvPr id="2" name="TextBox 1"/>
+          <p:cNvSpPr txBox="1"/>
+          <p:nvPr/>
+        </p:nvSpPr>
+        <p:spPr>
+          <a:xfrm>
+            <a:off x="822960" y="502920"/>
+            <a:ext cx="5486400" cy="457200"/>
+          </a:xfrm>
+          <a:prstGeom prst="rect">
+            <a:avLst/>
+          </a:prstGeom>
+          <a:noFill/>
+        </p:spPr>
+        <p:txBody>
+          <a:bodyPr wrap="square">
+            <a:spAutoFit/>
+          </a:bodyPr>
+          <a:lstStyle/>
+          <a:p>
+            <a:pPr algn="l">
+              <a:spcAft>
+                <a:spcPts val="800"/>
+              </a:spcAft>
+            </a:pPr>
+            <a:r>
+              <a:rPr sz="1600" b="1">
+                <a:solidFill>
+                  <a:srgbClr val="E8B46A"/>
+                </a:solidFill>
+                <a:latin typeface="Segoe UI"/>
+              </a:rPr>
+              <a:t>STANDING ON OPEN SOURCE 💙</a:t>
+            </a:r>
+          </a:p>
+        </p:txBody>
+      </p:sp>
+      <p:sp>
+        <p:nvSpPr>
+          <p:cNvPr id="3" name="TextBox 2"/>
+          <p:cNvSpPr txBox="1"/>
+          <p:nvPr/>
+        </p:nvSpPr>
+        <p:spPr>
+          <a:xfrm>
+            <a:off x="777240" y="868680"/>
+            <a:ext cx="10607040" cy="1188720"/>
+          </a:xfrm>
+          <a:prstGeom prst="rect">
+            <a:avLst/>
+          </a:prstGeom>
+          <a:noFill/>
+        </p:spPr>
+        <p:txBody>
+          <a:bodyPr wrap="square">
+            <a:spAutoFit/>
+          </a:bodyPr>
+          <a:lstStyle/>
+          <a:p>
+            <a:pPr algn="l">
+              <a:spcAft>
+                <a:spcPts val="800"/>
+              </a:spcAft>
+            </a:pPr>
+            <a:r>
+              <a:rPr sz="3600" b="1">
+                <a:solidFill>
+                  <a:srgbClr val="F7F7F0"/>
+                </a:solidFill>
+                <a:latin typeface="Segoe UI"/>
+              </a:rPr>
+              <a:t>Built with open source, agent by agent 🌊</a:t>
+            </a:r>
+          </a:p>
+        </p:txBody>
+      </p:sp>
+      <p:sp>
+        <p:nvSpPr>
+          <p:cNvPr id="4" name="Rounded Rectangle 3"/>
+          <p:cNvSpPr/>
+          <p:nvPr/>
+        </p:nvSpPr>
+        <p:spPr>
+          <a:xfrm>
+            <a:off x="1005840" y="1874519"/>
+            <a:ext cx="3264408" cy="1691640"/>
+          </a:xfrm>
+          <a:prstGeom prst="roundRect">
+            <a:avLst/>
+          </a:prstGeom>
+          <a:solidFill>
+            <a:srgbClr val="242C4E"/>
+          </a:solidFill>
+          <a:ln>
+            <a:noFill/>
+          </a:ln>
+          <a:effectLst/>
+        </p:spPr>
+        <p:style>
+          <a:lnRef idx="1">
+            <a:schemeClr val="accent1"/>
+          </a:lnRef>
+          <a:fillRef idx="3">
+            <a:schemeClr val="accent1"/>
+          </a:fillRef>
+          <a:effectRef idx="2">
+            <a:schemeClr val="accent1"/>
+          </a:effectRef>
+          <a:fontRef idx="minor">
+            <a:schemeClr val="lt1"/>
+          </a:fontRef>
+        </p:style>
+        <p:txBody>
+          <a:bodyPr rtlCol="0" anchor="ctr"/>
+          <a:lstStyle/>
+          <a:p>
+            <a:pPr algn="ctr"/>
+          </a:p>
+        </p:txBody>
+      </p:sp>
+      <p:sp>
+        <p:nvSpPr>
+          <p:cNvPr id="5" name="TextBox 4"/>
+          <p:cNvSpPr txBox="1"/>
+          <p:nvPr/>
+        </p:nvSpPr>
+        <p:spPr>
+          <a:xfrm>
+            <a:off x="1325880" y="1984248"/>
+            <a:ext cx="2624328" cy="1472184"/>
+          </a:xfrm>
+          <a:prstGeom prst="rect">
+            <a:avLst/>
+          </a:prstGeom>
+          <a:noFill/>
+        </p:spPr>
+        <p:txBody>
+          <a:bodyPr wrap="square">
+            <a:spAutoFit/>
+          </a:bodyPr>
+          <a:lstStyle/>
+          <a:p>
+            <a:pPr algn="l">
+              <a:spcAft>
+                <a:spcPts val="800"/>
+              </a:spcAft>
+            </a:pPr>
+            <a:r>
+              <a:rPr sz="1700" b="1">
+                <a:solidFill>
+                  <a:srgbClr val="E8B46A"/>
+                </a:solidFill>
+                <a:latin typeface="Segoe UI"/>
+              </a:rPr>
+              <a:t>🛳️ Scheduler agent</a:t>
+            </a:r>
+          </a:p>
+          <a:p>
+            <a:pPr algn="l">
+              <a:spcAft>
+                <a:spcPts val="800"/>
+              </a:spcAft>
+            </a:pPr>
+            <a:r>
+              <a:rPr sz="1350" b="0">
+                <a:solidFill>
+                  <a:srgbClr val="EDEDDD"/>
+                </a:solidFill>
+                <a:latin typeface="Segoe UI"/>
+              </a:rPr>
+              <a:t>LangGraph plan-and-execute  ·  obsidian-magic-tasks  ·  study-revision-planner</a:t>
+            </a:r>
+          </a:p>
+        </p:txBody>
+      </p:sp>
+      <p:sp>
+        <p:nvSpPr>
+          <p:cNvPr id="6" name="Rounded Rectangle 5"/>
+          <p:cNvSpPr/>
+          <p:nvPr/>
+        </p:nvSpPr>
+        <p:spPr>
+          <a:xfrm>
+            <a:off x="4453128" y="1874519"/>
+            <a:ext cx="3264408" cy="1691640"/>
+          </a:xfrm>
+          <a:prstGeom prst="roundRect">
+            <a:avLst/>
+          </a:prstGeom>
+          <a:solidFill>
+            <a:srgbClr val="242C4E"/>
+          </a:solidFill>
+          <a:ln>
+            <a:noFill/>
+          </a:ln>
+          <a:effectLst/>
+        </p:spPr>
+        <p:style>
+          <a:lnRef idx="1">
+            <a:schemeClr val="accent1"/>
+          </a:lnRef>
+          <a:fillRef idx="3">
+            <a:schemeClr val="accent1"/>
+          </a:fillRef>
+          <a:effectRef idx="2">
+            <a:schemeClr val="accent1"/>
+          </a:effectRef>
+          <a:fontRef idx="minor">
+            <a:schemeClr val="lt1"/>
+          </a:fontRef>
+        </p:style>
+        <p:txBody>
+          <a:bodyPr rtlCol="0" anchor="ctr"/>
+          <a:lstStyle/>
+          <a:p>
+            <a:pPr algn="ctr"/>
+          </a:p>
+        </p:txBody>
+      </p:sp>
+      <p:sp>
+        <p:nvSpPr>
+          <p:cNvPr id="7" name="TextBox 6"/>
+          <p:cNvSpPr txBox="1"/>
+          <p:nvPr/>
+        </p:nvSpPr>
+        <p:spPr>
+          <a:xfrm>
+            <a:off x="4773168" y="1984248"/>
+            <a:ext cx="2624328" cy="1472184"/>
+          </a:xfrm>
+          <a:prstGeom prst="rect">
+            <a:avLst/>
+          </a:prstGeom>
+          <a:noFill/>
+        </p:spPr>
+        <p:txBody>
+          <a:bodyPr wrap="square">
+            <a:spAutoFit/>
+          </a:bodyPr>
+          <a:lstStyle/>
+          <a:p>
+            <a:pPr algn="l">
+              <a:spcAft>
+                <a:spcPts val="800"/>
+              </a:spcAft>
+            </a:pPr>
+            <a:r>
+              <a:rPr sz="1700" b="1">
+                <a:solidFill>
+                  <a:srgbClr val="E8B46A"/>
+                </a:solidFill>
+                <a:latin typeface="Segoe UI"/>
+              </a:rPr>
+              <a:t>⛵ Flashcard agent</a:t>
+            </a:r>
+          </a:p>
+          <a:p>
+            <a:pPr algn="l">
+              <a:spcAft>
+                <a:spcPts val="800"/>
+              </a:spcAft>
+            </a:pPr>
+            <a:r>
+              <a:rPr sz="1350" b="0">
+                <a:solidFill>
+                  <a:srgbClr val="EDEDDD"/>
+                </a:solidFill>
+                <a:latin typeface="Segoe UI"/>
+              </a:rPr>
+              <a:t>anki-llm-flashcard-generator (forked)  ·  py-fsrs  ·  genanki</a:t>
+            </a:r>
+          </a:p>
+        </p:txBody>
+      </p:sp>
+      <p:sp>
+        <p:nvSpPr>
+          <p:cNvPr id="8" name="Rounded Rectangle 7"/>
+          <p:cNvSpPr/>
+          <p:nvPr/>
+        </p:nvSpPr>
+        <p:spPr>
+          <a:xfrm>
+            <a:off x="7900416" y="1874519"/>
+            <a:ext cx="3264408" cy="1691640"/>
+          </a:xfrm>
+          <a:prstGeom prst="roundRect">
+            <a:avLst/>
+          </a:prstGeom>
+          <a:solidFill>
+            <a:srgbClr val="242C4E"/>
+          </a:solidFill>
+          <a:ln>
+            <a:noFill/>
+          </a:ln>
+          <a:effectLst/>
+        </p:spPr>
+        <p:style>
+          <a:lnRef idx="1">
+            <a:schemeClr val="accent1"/>
+          </a:lnRef>
+          <a:fillRef idx="3">
+            <a:schemeClr val="accent1"/>
+          </a:fillRef>
+          <a:effectRef idx="2">
+            <a:schemeClr val="accent1"/>
+          </a:effectRef>
+          <a:fontRef idx="minor">
+            <a:schemeClr val="lt1"/>
+          </a:fontRef>
+        </p:style>
+        <p:txBody>
+          <a:bodyPr rtlCol="0" anchor="ctr"/>
+          <a:lstStyle/>
+          <a:p>
+            <a:pPr algn="ctr"/>
+          </a:p>
+        </p:txBody>
+      </p:sp>
+      <p:sp>
+        <p:nvSpPr>
+          <p:cNvPr id="9" name="TextBox 8"/>
+          <p:cNvSpPr txBox="1"/>
+          <p:nvPr/>
+        </p:nvSpPr>
+        <p:spPr>
+          <a:xfrm>
+            <a:off x="8220456" y="1984248"/>
+            <a:ext cx="2624328" cy="1472184"/>
+          </a:xfrm>
+          <a:prstGeom prst="rect">
+            <a:avLst/>
+          </a:prstGeom>
+          <a:noFill/>
+        </p:spPr>
+        <p:txBody>
+          <a:bodyPr wrap="square">
+            <a:spAutoFit/>
+          </a:bodyPr>
+          <a:lstStyle/>
+          <a:p>
+            <a:pPr algn="l">
+              <a:spcAft>
+                <a:spcPts val="800"/>
+              </a:spcAft>
+            </a:pPr>
+            <a:r>
+              <a:rPr sz="1700" b="1">
+                <a:solidFill>
+                  <a:srgbClr val="E8B46A"/>
+                </a:solidFill>
+                <a:latin typeface="Segoe UI"/>
+              </a:rPr>
+              <a:t>🌊 Knowledge graph</a:t>
+            </a:r>
+          </a:p>
+          <a:p>
+            <a:pPr algn="l">
+              <a:spcAft>
+                <a:spcPts val="800"/>
+              </a:spcAft>
+            </a:pPr>
+            <a:r>
+              <a:rPr sz="1350" b="0">
+                <a:solidFill>
+                  <a:srgbClr val="EDEDDD"/>
+                </a:solidFill>
+                <a:latin typeface="Segoe UI"/>
+              </a:rPr>
+              <a:t>langchain-experimental graph transformer  ·  nano-graphrag  ·  KeyBERT</a:t>
+            </a:r>
+          </a:p>
+        </p:txBody>
+      </p:sp>
+      <p:sp>
+        <p:nvSpPr>
+          <p:cNvPr id="10" name="Rounded Rectangle 9"/>
+          <p:cNvSpPr/>
+          <p:nvPr/>
+        </p:nvSpPr>
+        <p:spPr>
+          <a:xfrm>
+            <a:off x="1005840" y="3794760"/>
+            <a:ext cx="3264408" cy="1691640"/>
+          </a:xfrm>
+          <a:prstGeom prst="roundRect">
+            <a:avLst/>
+          </a:prstGeom>
+          <a:solidFill>
+            <a:srgbClr val="242C4E"/>
+          </a:solidFill>
+          <a:ln>
+            <a:noFill/>
+          </a:ln>
+          <a:effectLst/>
+        </p:spPr>
+        <p:style>
+          <a:lnRef idx="1">
+            <a:schemeClr val="accent1"/>
+          </a:lnRef>
+          <a:fillRef idx="3">
+            <a:schemeClr val="accent1"/>
+          </a:fillRef>
+          <a:effectRef idx="2">
+            <a:schemeClr val="accent1"/>
+          </a:effectRef>
+          <a:fontRef idx="minor">
+            <a:schemeClr val="lt1"/>
+          </a:fontRef>
+        </p:style>
+        <p:txBody>
+          <a:bodyPr rtlCol="0" anchor="ctr"/>
+          <a:lstStyle/>
+          <a:p>
+            <a:pPr algn="ctr"/>
+          </a:p>
+        </p:txBody>
+      </p:sp>
+      <p:sp>
+        <p:nvSpPr>
+          <p:cNvPr id="11" name="TextBox 10"/>
+          <p:cNvSpPr txBox="1"/>
+          <p:nvPr/>
+        </p:nvSpPr>
+        <p:spPr>
+          <a:xfrm>
+            <a:off x="1325880" y="3904488"/>
+            <a:ext cx="2624328" cy="1472184"/>
+          </a:xfrm>
+          <a:prstGeom prst="rect">
+            <a:avLst/>
+          </a:prstGeom>
+          <a:noFill/>
+        </p:spPr>
+        <p:txBody>
+          <a:bodyPr wrap="square">
+            <a:spAutoFit/>
+          </a:bodyPr>
+          <a:lstStyle/>
+          <a:p>
+            <a:pPr algn="l">
+              <a:spcAft>
+                <a:spcPts val="800"/>
+              </a:spcAft>
+            </a:pPr>
+            <a:r>
+              <a:rPr sz="1700" b="1">
+                <a:solidFill>
+                  <a:srgbClr val="E8B46A"/>
+                </a:solidFill>
+                <a:latin typeface="Segoe UI"/>
+              </a:rPr>
+              <a:t>🧭 Orchestrator</a:t>
+            </a:r>
+          </a:p>
+          <a:p>
+            <a:pPr algn="l">
+              <a:spcAft>
+                <a:spcPts val="800"/>
+              </a:spcAft>
+            </a:pPr>
+            <a:r>
+              <a:rPr sz="1350" b="0">
+                <a:solidFill>
+                  <a:srgbClr val="EDEDDD"/>
+                </a:solidFill>
+                <a:latin typeface="Segoe UI"/>
+              </a:rPr>
+              <a:t>fastapi-langgraph-template  ·  langgraph-swarm handoffs</a:t>
+            </a:r>
+          </a:p>
+        </p:txBody>
+      </p:sp>
+      <p:sp>
+        <p:nvSpPr>
+          <p:cNvPr id="12" name="Rounded Rectangle 11"/>
+          <p:cNvSpPr/>
+          <p:nvPr/>
+        </p:nvSpPr>
+        <p:spPr>
+          <a:xfrm>
+            <a:off x="4453128" y="3794760"/>
+            <a:ext cx="3264408" cy="1691640"/>
+          </a:xfrm>
+          <a:prstGeom prst="roundRect">
+            <a:avLst/>
+          </a:prstGeom>
+          <a:solidFill>
+            <a:srgbClr val="242C4E"/>
+          </a:solidFill>
+          <a:ln>
+            <a:noFill/>
+          </a:ln>
+          <a:effectLst/>
+        </p:spPr>
+        <p:style>
+          <a:lnRef idx="1">
+            <a:schemeClr val="accent1"/>
+          </a:lnRef>
+          <a:fillRef idx="3">
+            <a:schemeClr val="accent1"/>
+          </a:fillRef>
+          <a:effectRef idx="2">
+            <a:schemeClr val="accent1"/>
+          </a:effectRef>
+          <a:fontRef idx="minor">
+            <a:schemeClr val="lt1"/>
+          </a:fontRef>
+        </p:style>
+        <p:txBody>
+          <a:bodyPr rtlCol="0" anchor="ctr"/>
+          <a:lstStyle/>
+          <a:p>
+            <a:pPr algn="ctr"/>
+          </a:p>
+        </p:txBody>
+      </p:sp>
+      <p:sp>
+        <p:nvSpPr>
+          <p:cNvPr id="13" name="TextBox 12"/>
+          <p:cNvSpPr txBox="1"/>
+          <p:nvPr/>
+        </p:nvSpPr>
+        <p:spPr>
+          <a:xfrm>
+            <a:off x="4773168" y="3904488"/>
+            <a:ext cx="2624328" cy="1472184"/>
+          </a:xfrm>
+          <a:prstGeom prst="rect">
+            <a:avLst/>
+          </a:prstGeom>
+          <a:noFill/>
+        </p:spPr>
+        <p:txBody>
+          <a:bodyPr wrap="square">
+            <a:spAutoFit/>
+          </a:bodyPr>
+          <a:lstStyle/>
+          <a:p>
+            <a:pPr algn="l">
+              <a:spcAft>
+                <a:spcPts val="800"/>
+              </a:spcAft>
+            </a:pPr>
+            <a:r>
+              <a:rPr sz="1700" b="1">
+                <a:solidFill>
+                  <a:srgbClr val="E8B46A"/>
+                </a:solidFill>
+                <a:latin typeface="Segoe UI"/>
+              </a:rPr>
+              <a:t>🎨 World rendering</a:t>
+            </a:r>
+          </a:p>
+          <a:p>
+            <a:pPr algn="l">
+              <a:spcAft>
+                <a:spcPts val="800"/>
+              </a:spcAft>
+            </a:pPr>
+            <a:r>
+              <a:rPr sz="1350" b="0">
+                <a:solidFill>
+                  <a:srgbClr val="EDEDDD"/>
+                </a:solidFill>
+                <a:latin typeface="Segoe UI"/>
+              </a:rPr>
+              <a:t>stylized-water shaders  ·  camera-controls  ·  underwater-atlas engine (three.js + GLSL)</a:t>
+            </a:r>
+          </a:p>
+        </p:txBody>
+      </p:sp>
+      <p:sp>
+        <p:nvSpPr>
+          <p:cNvPr id="14" name="Rounded Rectangle 13"/>
+          <p:cNvSpPr/>
+          <p:nvPr/>
+        </p:nvSpPr>
+        <p:spPr>
+          <a:xfrm>
+            <a:off x="7900416" y="3794760"/>
+            <a:ext cx="3264408" cy="1691640"/>
+          </a:xfrm>
+          <a:prstGeom prst="roundRect">
+            <a:avLst/>
+          </a:prstGeom>
+          <a:solidFill>
+            <a:srgbClr val="242C4E"/>
+          </a:solidFill>
+          <a:ln>
+            <a:noFill/>
+          </a:ln>
+          <a:effectLst/>
+        </p:spPr>
+        <p:style>
+          <a:lnRef idx="1">
+            <a:schemeClr val="accent1"/>
+          </a:lnRef>
+          <a:fillRef idx="3">
+            <a:schemeClr val="accent1"/>
+          </a:fillRef>
+          <a:effectRef idx="2">
+            <a:schemeClr val="accent1"/>
+          </a:effectRef>
+          <a:fontRef idx="minor">
+            <a:schemeClr val="lt1"/>
+          </a:fontRef>
+        </p:style>
+        <p:txBody>
+          <a:bodyPr rtlCol="0" anchor="ctr"/>
+          <a:lstStyle/>
+          <a:p>
+            <a:pPr algn="ctr"/>
+          </a:p>
+        </p:txBody>
+      </p:sp>
+      <p:sp>
+        <p:nvSpPr>
+          <p:cNvPr id="15" name="TextBox 14"/>
+          <p:cNvSpPr txBox="1"/>
+          <p:nvPr/>
+        </p:nvSpPr>
+        <p:spPr>
+          <a:xfrm>
+            <a:off x="8220456" y="3904488"/>
+            <a:ext cx="2624328" cy="1472184"/>
+          </a:xfrm>
+          <a:prstGeom prst="rect">
+            <a:avLst/>
+          </a:prstGeom>
+          <a:noFill/>
+        </p:spPr>
+        <p:txBody>
+          <a:bodyPr wrap="square">
+            <a:spAutoFit/>
+          </a:bodyPr>
+          <a:lstStyle/>
+          <a:p>
+            <a:pPr algn="l">
+              <a:spcAft>
+                <a:spcPts val="800"/>
+              </a:spcAft>
+            </a:pPr>
+            <a:r>
+              <a:rPr sz="1700" b="1">
+                <a:solidFill>
+                  <a:srgbClr val="E8B46A"/>
+                </a:solidFill>
+                <a:latin typeface="Segoe UI"/>
+              </a:rPr>
+              <a:t>🧱 3D assets</a:t>
+            </a:r>
+          </a:p>
+          <a:p>
+            <a:pPr algn="l">
+              <a:spcAft>
+                <a:spcPts val="800"/>
+              </a:spcAft>
+            </a:pPr>
+            <a:r>
+              <a:rPr sz="1350" b="0">
+                <a:solidFill>
+                  <a:srgbClr val="EDEDDD"/>
+                </a:solidFill>
+                <a:latin typeface="Segoe UI"/>
+              </a:rPr>
+              <a:t>Kenney CC0 boats  ·  custom Blender fishboat + lamp buoy</a:t>
+            </a:r>
+          </a:p>
+        </p:txBody>
+      </p:sp>
+      <p:sp>
+        <p:nvSpPr>
+          <p:cNvPr id="16" name="TextBox 15"/>
+          <p:cNvSpPr txBox="1"/>
+          <p:nvPr/>
+        </p:nvSpPr>
+        <p:spPr>
+          <a:xfrm>
+            <a:off x="914400" y="5715000"/>
+            <a:ext cx="10332720" cy="457200"/>
+          </a:xfrm>
+          <a:prstGeom prst="rect">
+            <a:avLst/>
+          </a:prstGeom>
+          <a:noFill/>
+        </p:spPr>
+        <p:txBody>
+          <a:bodyPr wrap="square">
+            <a:spAutoFit/>
+          </a:bodyPr>
+          <a:lstStyle/>
+          <a:p>
+            <a:pPr algn="ctr">
+              <a:spcAft>
+                <a:spcPts val="800"/>
+              </a:spcAft>
+            </a:pPr>
+            <a:r>
+              <a:rPr sz="1500" b="0">
+                <a:solidFill>
+                  <a:srgbClr val="D8E4E0"/>
+                </a:solidFill>
+                <a:latin typeface="Segoe UI"/>
+              </a:rPr>
+              <a:t>full credit list  →  opensource/README.md 📜</a:t>
+            </a:r>
+          </a:p>
+        </p:txBody>
+      </p:sp>
+      <p:sp>
+        <p:nvSpPr>
+          <p:cNvPr id="17" name="Rectangle 16"/>
+          <p:cNvSpPr/>
+          <p:nvPr/>
+        </p:nvSpPr>
+        <p:spPr>
+          <a:xfrm>
+            <a:off x="502920" y="6473952"/>
+            <a:ext cx="457200" cy="41148"/>
+          </a:xfrm>
+          <a:prstGeom prst="rect">
+            <a:avLst/>
+          </a:prstGeom>
+          <a:solidFill>
+            <a:srgbClr val="D8E4E0"/>
+          </a:solidFill>
+          <a:ln>
+            <a:noFill/>
+          </a:ln>
+          <a:effectLst/>
+        </p:spPr>
+        <p:style>
+          <a:lnRef idx="1">
+            <a:schemeClr val="accent1"/>
+          </a:lnRef>
+          <a:fillRef idx="3">
+            <a:schemeClr val="accent1"/>
+          </a:fillRef>
+          <a:effectRef idx="2">
+            <a:schemeClr val="accent1"/>
+          </a:effectRef>
+          <a:fontRef idx="minor">
+            <a:schemeClr val="lt1"/>
+          </a:fontRef>
+        </p:style>
+        <p:txBody>
+          <a:bodyPr rtlCol="0" anchor="ctr"/>
+          <a:lstStyle/>
+          <a:p>
+            <a:pPr algn="ctr"/>
+          </a:p>
+        </p:txBody>
+      </p:sp>
+      <p:sp>
+        <p:nvSpPr>
+          <p:cNvPr id="18" name="TextBox 17"/>
+          <p:cNvSpPr txBox="1"/>
+          <p:nvPr/>
+        </p:nvSpPr>
+        <p:spPr>
+          <a:xfrm>
+            <a:off x="502920" y="6108192"/>
+            <a:ext cx="2743200" cy="365760"/>
+          </a:xfrm>
+          <a:prstGeom prst="rect">
+            <a:avLst/>
+          </a:prstGeom>
+          <a:noFill/>
+        </p:spPr>
+        <p:txBody>
+          <a:bodyPr wrap="square">
+            <a:spAutoFit/>
+          </a:bodyPr>
+          <a:lstStyle/>
+          <a:p>
+            <a:pPr algn="l">
+              <a:spcAft>
+                <a:spcPts val="800"/>
+              </a:spcAft>
+            </a:pPr>
+            <a:r>
+              <a:rPr sz="1200" b="1">
+                <a:solidFill>
+                  <a:srgbClr val="D8E4E0"/>
+                </a:solidFill>
+                <a:latin typeface="Segoe UI"/>
+              </a:rPr>
+              <a:t>enjoy ⚓</a:t>
+            </a:r>
+          </a:p>
+        </p:txBody>
+      </p:sp>
+      <p:sp>
+        <p:nvSpPr>
+          <p:cNvPr id="19" name="TextBox 18"/>
+          <p:cNvSpPr txBox="1"/>
+          <p:nvPr/>
+        </p:nvSpPr>
+        <p:spPr>
+          <a:xfrm>
+            <a:off x="11155680" y="6108192"/>
+            <a:ext cx="548640" cy="365760"/>
+          </a:xfrm>
+          <a:prstGeom prst="rect">
+            <a:avLst/>
+          </a:prstGeom>
+          <a:noFill/>
+        </p:spPr>
+        <p:txBody>
+          <a:bodyPr wrap="square">
+            <a:spAutoFit/>
+          </a:bodyPr>
+          <a:lstStyle/>
+          <a:p>
+            <a:pPr algn="r">
+              <a:spcAft>
+                <a:spcPts val="800"/>
+              </a:spcAft>
+            </a:pPr>
+            <a:r>
+              <a:rPr sz="1200" b="1">
+                <a:solidFill>
+                  <a:srgbClr val="D8E4E0"/>
+                </a:solidFill>
+                <a:latin typeface="Segoe UI"/>
+              </a:rPr>
+              <a:t>08</a:t>
+            </a:r>
+          </a:p>
+        </p:txBody>
+      </p:sp>
+    </p:spTree>
+  </p:cSld>
+  <p:clrMapOvr>
+    <a:masterClrMapping/>
+  </p:clrMapOvr>
+</p:sld>
+</file>
+
+<file path=ppt/slides/slide9.xml><?xml version="1.0" encoding="utf-8"?>
 <p:sld xmlns:a="http://schemas.openxmlformats.org/drawingml/2006/main" xmlns:p="http://schemas.openxmlformats.org/presentationml/2006/main" xmlns:r="http://schemas.openxmlformats.org/officeDocument/2006/relationships">
   <p:cSld>
     <p:bg>
@@ -7211,7 +8695,7 @@
                 </a:solidFill>
                 <a:latin typeface="Segoe UI"/>
               </a:rPr>
-              <a:t>08</a:t>
+              <a:t>09</a:t>
             </a:r>
           </a:p>
         </p:txBody>

</xml_diff>